<commit_message>
Presentacion: insertar capturas reales del sistema en los 4 pasos
Capturas reales de la app (logo BCE, tema oscuro) en los pasos I-IV:
carga de reportes, matriz con semaforo, gestion de observaciones
(diagnostico por prestamo) y emision del oficio (Quipux), con pie de foto.

Co-Authored-By: Claude Opus 4.8 <noreply@anthropic.com>
Claude-Session: https://claude.ai/code/session_01L8afBmxSSw3uGuopVyT6Ha
</commit_message>
<xml_diff>
--- a/Presentacion_Conciliacion_BCE.pptx
+++ b/Presentacion_Conciliacion_BCE.pptx
@@ -5360,16 +5360,45 @@
           </a:p>
         </p:txBody>
       </p:sp>
-      <p:sp>
-        <p:nvSpPr>
-          <p:cNvPr id="5" name="TextBox 4"/>
+      <p:pic>
+        <p:nvPicPr>
+          <p:cNvPr id="5" name="Picture 4" descr="s1_carga.png"/>
+          <p:cNvPicPr>
+            <a:picLocks noChangeAspect="1"/>
+          </p:cNvPicPr>
+          <p:nvPr/>
+        </p:nvPicPr>
+        <p:blipFill>
+          <a:blip r:embed="rId2"/>
+          <a:stretch>
+            <a:fillRect/>
+          </a:stretch>
+        </p:blipFill>
+        <p:spPr>
+          <a:xfrm>
+            <a:off x="1394460" y="1097280"/>
+            <a:ext cx="6355080" cy="3575304"/>
+          </a:xfrm>
+          <a:prstGeom prst="rect">
+            <a:avLst/>
+          </a:prstGeom>
+          <a:ln w="9525">
+            <a:solidFill>
+              <a:srgbClr val="0072CE"/>
+            </a:solidFill>
+          </a:ln>
+        </p:spPr>
+      </p:pic>
+      <p:sp>
+        <p:nvSpPr>
+          <p:cNvPr id="6" name="TextBox 5"/>
           <p:cNvSpPr txBox="1"/>
           <p:nvPr/>
         </p:nvSpPr>
         <p:spPr>
           <a:xfrm>
-            <a:off x="566928" y="1417320"/>
-            <a:ext cx="7845552" cy="3177540"/>
+            <a:off x="548640" y="4736592"/>
+            <a:ext cx="8046720" cy="320040"/>
           </a:xfrm>
           <a:prstGeom prst="rect">
             <a:avLst/>
@@ -5382,67 +5411,15 @@
           </a:bodyPr>
           <a:lstStyle/>
           <a:p>
-            <a:pPr>
-              <a:spcAft>
-                <a:spcPts val="1000"/>
-              </a:spcAft>
-            </a:pPr>
-            <a:r>
-              <a:rPr sz="1500" b="0" i="0">
-                <a:solidFill>
-                  <a:srgbClr val="58595B"/>
+            <a:pPr algn="ctr"/>
+            <a:r>
+              <a:rPr sz="1100" b="0" i="1">
+                <a:solidFill>
+                  <a:srgbClr val="8A8C8F"/>
                 </a:solidFill>
                 <a:latin typeface="Calibri"/>
               </a:rPr>
-              <a:t>●  Una sola zona para arrastrar o cargar ambos reportes (.xls / .xlsx).</a:t>
-            </a:r>
-          </a:p>
-          <a:p>
-            <a:pPr>
-              <a:spcAft>
-                <a:spcPts val="1000"/>
-              </a:spcAft>
-            </a:pPr>
-            <a:r>
-              <a:rPr sz="1500" b="0" i="0">
-                <a:solidFill>
-                  <a:srgbClr val="58595B"/>
-                </a:solidFill>
-                <a:latin typeface="Calibri"/>
-              </a:rPr>
-              <a:t>●  No importa el orden: el sistema reconoce cuál es MEF y cuál BCE.</a:t>
-            </a:r>
-          </a:p>
-          <a:p>
-            <a:pPr>
-              <a:spcAft>
-                <a:spcPts val="1000"/>
-              </a:spcAft>
-            </a:pPr>
-            <a:r>
-              <a:rPr sz="1500" b="0" i="0">
-                <a:solidFill>
-                  <a:srgbClr val="58595B"/>
-                </a:solidFill>
-                <a:latin typeface="Calibri"/>
-              </a:rPr>
-              <a:t>●  El período se detecta automáticamente del archivo (ej. “Marzo 2026”).</a:t>
-            </a:r>
-          </a:p>
-          <a:p>
-            <a:pPr>
-              <a:spcAft>
-                <a:spcPts val="1000"/>
-              </a:spcAft>
-            </a:pPr>
-            <a:r>
-              <a:rPr sz="1500" b="1" i="0">
-                <a:solidFill>
-                  <a:srgbClr val="003A70"/>
-                </a:solidFill>
-                <a:latin typeface="Calibri"/>
-              </a:rPr>
-              <a:t>●  Sin configurar nada: listo para conciliar en segundos.</a:t>
+              <a:t>Una sola zona: se arrastran los dos reportes (MEF y BCE); el período se detecta automáticamente.</a:t>
             </a:r>
           </a:p>
         </p:txBody>
@@ -5571,21 +5548,50 @@
                 </a:solidFill>
                 <a:latin typeface="Calibri"/>
               </a:rPr>
-              <a:t>Resultado con semáforo</a:t>
-            </a:r>
-          </a:p>
-        </p:txBody>
-      </p:sp>
-      <p:sp>
-        <p:nvSpPr>
-          <p:cNvPr id="5" name="TextBox 4"/>
+              <a:t>Matriz con semáforo y total general</a:t>
+            </a:r>
+          </a:p>
+        </p:txBody>
+      </p:sp>
+      <p:pic>
+        <p:nvPicPr>
+          <p:cNvPr id="5" name="Picture 4" descr="s2_resultados.png"/>
+          <p:cNvPicPr>
+            <a:picLocks noChangeAspect="1"/>
+          </p:cNvPicPr>
+          <p:nvPr/>
+        </p:nvPicPr>
+        <p:blipFill>
+          <a:blip r:embed="rId2"/>
+          <a:stretch>
+            <a:fillRect/>
+          </a:stretch>
+        </p:blipFill>
+        <p:spPr>
+          <a:xfrm>
+            <a:off x="1394460" y="1097280"/>
+            <a:ext cx="6355080" cy="3575304"/>
+          </a:xfrm>
+          <a:prstGeom prst="rect">
+            <a:avLst/>
+          </a:prstGeom>
+          <a:ln w="9525">
+            <a:solidFill>
+              <a:srgbClr val="0072CE"/>
+            </a:solidFill>
+          </a:ln>
+        </p:spPr>
+      </p:pic>
+      <p:sp>
+        <p:nvSpPr>
+          <p:cNvPr id="6" name="TextBox 5"/>
           <p:cNvSpPr txBox="1"/>
           <p:nvPr/>
         </p:nvSpPr>
         <p:spPr>
           <a:xfrm>
-            <a:off x="566928" y="1417320"/>
-            <a:ext cx="7845552" cy="3177540"/>
+            <a:off x="548640" y="4736592"/>
+            <a:ext cx="8046720" cy="320040"/>
           </a:xfrm>
           <a:prstGeom prst="rect">
             <a:avLst/>
@@ -5598,83 +5604,15 @@
           </a:bodyPr>
           <a:lstStyle/>
           <a:p>
-            <a:pPr>
-              <a:spcAft>
-                <a:spcPts val="1000"/>
-              </a:spcAft>
-            </a:pPr>
-            <a:r>
-              <a:rPr sz="1500" b="0" i="0">
-                <a:solidFill>
-                  <a:srgbClr val="58595B"/>
+            <a:pPr algn="ctr"/>
+            <a:r>
+              <a:rPr sz="1100" b="0" i="1">
+                <a:solidFill>
+                  <a:srgbClr val="8A8C8F"/>
                 </a:solidFill>
                 <a:latin typeface="Calibri"/>
               </a:rPr>
-              <a:t>●  Matriz por cartera con los 6 rubros: MEF · BCE · Diferencia.</a:t>
-            </a:r>
-          </a:p>
-          <a:p>
-            <a:pPr>
-              <a:spcAft>
-                <a:spcPts val="1000"/>
-              </a:spcAft>
-            </a:pPr>
-            <a:r>
-              <a:rPr sz="1500" b="0" i="0">
-                <a:solidFill>
-                  <a:srgbClr val="58595B"/>
-                </a:solidFill>
-                <a:latin typeface="Calibri"/>
-              </a:rPr>
-              <a:t>●  Estado por cartera: CONCILIADO (verde) / DIFERENCIA (rojo) y fila TOTAL GENERAL.</a:t>
-            </a:r>
-          </a:p>
-          <a:p>
-            <a:pPr>
-              <a:spcAft>
-                <a:spcPts val="1000"/>
-              </a:spcAft>
-            </a:pPr>
-            <a:r>
-              <a:rPr sz="1500" b="0" i="0">
-                <a:solidFill>
-                  <a:srgbClr val="58595B"/>
-                </a:solidFill>
-                <a:latin typeface="Calibri"/>
-              </a:rPr>
-              <a:t>●  Suma préstamo por préstamo; no copia subtotales (evita imprecisiones).</a:t>
-            </a:r>
-          </a:p>
-          <a:p>
-            <a:pPr>
-              <a:spcAft>
-                <a:spcPts val="1000"/>
-              </a:spcAft>
-            </a:pPr>
-            <a:r>
-              <a:rPr sz="1500" b="0" i="0">
-                <a:solidFill>
-                  <a:srgbClr val="58595B"/>
-                </a:solidFill>
-                <a:latin typeface="Calibri"/>
-              </a:rPr>
-              <a:t>●  Ubica cada columna por su título: funciona aunque el BCE cambie el orden de columnas.</a:t>
-            </a:r>
-          </a:p>
-          <a:p>
-            <a:pPr lvl="1">
-              <a:spcAft>
-                <a:spcPts val="1000"/>
-              </a:spcAft>
-            </a:pPr>
-            <a:r>
-              <a:rPr sz="1500" b="0" i="0">
-                <a:solidFill>
-                  <a:srgbClr val="8A8C8F"/>
-                </a:solidFill>
-                <a:latin typeface="Calibri"/>
-              </a:rPr>
-              <a:t>–  Nota: se comparan “rubros con movimiento” (10 carteras × hasta 6 rubros = 27 este mes).</a:t>
+              <a:t>Matriz por cartera (MEF · BCE · Δ). Rojo = diferencia. Suma préstamo por préstamo, exacto al centavo.</a:t>
             </a:r>
           </a:p>
         </p:txBody>
@@ -5808,16 +5746,45 @@
           </a:p>
         </p:txBody>
       </p:sp>
-      <p:sp>
-        <p:nvSpPr>
-          <p:cNvPr id="5" name="TextBox 4"/>
+      <p:pic>
+        <p:nvPicPr>
+          <p:cNvPr id="5" name="Picture 4" descr="s3_observaciones.png"/>
+          <p:cNvPicPr>
+            <a:picLocks noChangeAspect="1"/>
+          </p:cNvPicPr>
+          <p:nvPr/>
+        </p:nvPicPr>
+        <p:blipFill>
+          <a:blip r:embed="rId2"/>
+          <a:stretch>
+            <a:fillRect/>
+          </a:stretch>
+        </p:blipFill>
+        <p:spPr>
+          <a:xfrm>
+            <a:off x="1394460" y="1097280"/>
+            <a:ext cx="6355080" cy="3575304"/>
+          </a:xfrm>
+          <a:prstGeom prst="rect">
+            <a:avLst/>
+          </a:prstGeom>
+          <a:ln w="9525">
+            <a:solidFill>
+              <a:srgbClr val="0072CE"/>
+            </a:solidFill>
+          </a:ln>
+        </p:spPr>
+      </p:pic>
+      <p:sp>
+        <p:nvSpPr>
+          <p:cNvPr id="6" name="TextBox 5"/>
           <p:cNvSpPr txBox="1"/>
           <p:nvPr/>
         </p:nvSpPr>
         <p:spPr>
           <a:xfrm>
-            <a:off x="566928" y="1417320"/>
-            <a:ext cx="7845552" cy="3177540"/>
+            <a:off x="548640" y="4736592"/>
+            <a:ext cx="8046720" cy="320040"/>
           </a:xfrm>
           <a:prstGeom prst="rect">
             <a:avLst/>
@@ -5830,83 +5797,15 @@
           </a:bodyPr>
           <a:lstStyle/>
           <a:p>
-            <a:pPr>
-              <a:spcAft>
-                <a:spcPts val="1000"/>
-              </a:spcAft>
-            </a:pPr>
-            <a:r>
-              <a:rPr sz="1500" b="0" i="0">
-                <a:solidFill>
-                  <a:srgbClr val="58595B"/>
+            <a:pPr algn="ctr"/>
+            <a:r>
+              <a:rPr sz="1100" b="0" i="1">
+                <a:solidFill>
+                  <a:srgbClr val="8A8C8F"/>
                 </a:solidFill>
                 <a:latin typeface="Calibri"/>
               </a:rPr>
-              <a:t>●  Por cada cartera con diferencia, señala el crédito específico:</a:t>
-            </a:r>
-          </a:p>
-          <a:p>
-            <a:pPr lvl="1">
-              <a:spcAft>
-                <a:spcPts val="1000"/>
-              </a:spcAft>
-            </a:pPr>
-            <a:r>
-              <a:rPr sz="1500" b="1" i="0">
-                <a:solidFill>
-                  <a:srgbClr val="C0392B"/>
-                </a:solidFill>
-                <a:latin typeface="Calibri"/>
-              </a:rPr>
-              <a:t>–  Ej. BIRF-8888 · Desembolsos · MEF 2.099.029,62 | BCE 0,00 | falta 2.099.029,62</a:t>
-            </a:r>
-          </a:p>
-          <a:p>
-            <a:pPr>
-              <a:spcAft>
-                <a:spcPts val="1000"/>
-              </a:spcAft>
-            </a:pPr>
-            <a:r>
-              <a:rPr sz="1500" b="0" i="0">
-                <a:solidFill>
-                  <a:srgbClr val="58595B"/>
-                </a:solidFill>
-                <a:latin typeface="Calibri"/>
-              </a:rPr>
-              <a:t>●  Clasifica la causa según la Observación del MEF: Pago Directo / Diferencial Cambiario / Revisar.</a:t>
-            </a:r>
-          </a:p>
-          <a:p>
-            <a:pPr>
-              <a:spcAft>
-                <a:spcPts val="1000"/>
-              </a:spcAft>
-            </a:pPr>
-            <a:r>
-              <a:rPr sz="1500" b="0" i="0">
-                <a:solidFill>
-                  <a:srgbClr val="58595B"/>
-                </a:solidFill>
-                <a:latin typeface="Calibri"/>
-              </a:rPr>
-              <a:t>●  Pago directo: se sube el respaldo del MEF y se agrega la fila al reporte del BCE con su nota.</a:t>
-            </a:r>
-          </a:p>
-          <a:p>
-            <a:pPr>
-              <a:spcAft>
-                <a:spcPts val="1000"/>
-              </a:spcAft>
-            </a:pPr>
-            <a:r>
-              <a:rPr sz="1500" b="1" i="0">
-                <a:solidFill>
-                  <a:srgbClr val="003A70"/>
-                </a:solidFill>
-                <a:latin typeface="Calibri"/>
-              </a:rPr>
-              <a:t>●  Cada ajuste agregado desaparece de la lista hasta que todo concilia.</a:t>
+              <a:t>Señala el crédito (ej. BIRF-8888), lo clasifica (Pago Directo) y permite subir el respaldo y agregarlo al BCE.</a:t>
             </a:r>
           </a:p>
         </p:txBody>
@@ -6035,21 +5934,50 @@
                 </a:solidFill>
                 <a:latin typeface="Calibri"/>
               </a:rPr>
-              <a:t>Solo si todas las carteras concilian</a:t>
-            </a:r>
-          </a:p>
-        </p:txBody>
-      </p:sp>
-      <p:sp>
-        <p:nvSpPr>
-          <p:cNvPr id="5" name="TextBox 4"/>
+              <a:t>El oficio de respuesta, automático</a:t>
+            </a:r>
+          </a:p>
+        </p:txBody>
+      </p:sp>
+      <p:pic>
+        <p:nvPicPr>
+          <p:cNvPr id="5" name="Picture 4" descr="s4_quipux.png"/>
+          <p:cNvPicPr>
+            <a:picLocks noChangeAspect="1"/>
+          </p:cNvPicPr>
+          <p:nvPr/>
+        </p:nvPicPr>
+        <p:blipFill>
+          <a:blip r:embed="rId2"/>
+          <a:stretch>
+            <a:fillRect/>
+          </a:stretch>
+        </p:blipFill>
+        <p:spPr>
+          <a:xfrm>
+            <a:off x="1394460" y="1097280"/>
+            <a:ext cx="6355080" cy="3575304"/>
+          </a:xfrm>
+          <a:prstGeom prst="rect">
+            <a:avLst/>
+          </a:prstGeom>
+          <a:ln w="9525">
+            <a:solidFill>
+              <a:srgbClr val="0072CE"/>
+            </a:solidFill>
+          </a:ln>
+        </p:spPr>
+      </p:pic>
+      <p:sp>
+        <p:nvSpPr>
+          <p:cNvPr id="6" name="TextBox 5"/>
           <p:cNvSpPr txBox="1"/>
           <p:nvPr/>
         </p:nvSpPr>
         <p:spPr>
           <a:xfrm>
-            <a:off x="566928" y="1417320"/>
-            <a:ext cx="7845552" cy="3177540"/>
+            <a:off x="548640" y="4736592"/>
+            <a:ext cx="8046720" cy="320040"/>
           </a:xfrm>
           <a:prstGeom prst="rect">
             <a:avLst/>
@@ -6062,83 +5990,15 @@
           </a:bodyPr>
           <a:lstStyle/>
           <a:p>
-            <a:pPr>
-              <a:spcAft>
-                <a:spcPts val="1000"/>
-              </a:spcAft>
-            </a:pPr>
-            <a:r>
-              <a:rPr sz="1500" b="0" i="0">
-                <a:solidFill>
-                  <a:srgbClr val="58595B"/>
+            <a:pPr algn="ctr"/>
+            <a:r>
+              <a:rPr sz="1100" b="0" i="1">
+                <a:solidFill>
+                  <a:srgbClr val="8A8C8F"/>
                 </a:solidFill>
                 <a:latin typeface="Calibri"/>
               </a:rPr>
-              <a:t>●  Genera el texto del oficio BCE → MEF, cartera por cartera.</a:t>
-            </a:r>
-          </a:p>
-          <a:p>
-            <a:pPr lvl="1">
-              <a:spcAft>
-                <a:spcPts val="1000"/>
-              </a:spcAft>
-            </a:pPr>
-            <a:r>
-              <a:rPr sz="1500" b="0" i="0">
-                <a:solidFill>
-                  <a:srgbClr val="58595B"/>
-                </a:solidFill>
-                <a:latin typeface="Calibri"/>
-              </a:rPr>
-              <a:t>–  Ej.: “BIRF: No existen observaciones en los rubros de desembolsos, amortizaciones, intereses, comisiones e intereses por mora.”</a:t>
-            </a:r>
-          </a:p>
-          <a:p>
-            <a:pPr>
-              <a:spcAft>
-                <a:spcPts val="1000"/>
-              </a:spcAft>
-            </a:pPr>
-            <a:r>
-              <a:rPr sz="1500" b="0" i="0">
-                <a:solidFill>
-                  <a:srgbClr val="58595B"/>
-                </a:solidFill>
-                <a:latin typeface="Calibri"/>
-              </a:rPr>
-              <a:t>●  Campos editables: N.º de oficio, destinatario, firmante y lista de copia.</a:t>
-            </a:r>
-          </a:p>
-          <a:p>
-            <a:pPr>
-              <a:spcAft>
-                <a:spcPts val="1000"/>
-              </a:spcAft>
-            </a:pPr>
-            <a:r>
-              <a:rPr sz="1500" b="0" i="0">
-                <a:solidFill>
-                  <a:srgbClr val="58595B"/>
-                </a:solidFill>
-                <a:latin typeface="Calibri"/>
-              </a:rPr>
-              <a:t>●  Copiar o descargar el texto para pegarlo en Quipux.</a:t>
-            </a:r>
-          </a:p>
-          <a:p>
-            <a:pPr>
-              <a:spcAft>
-                <a:spcPts val="1000"/>
-              </a:spcAft>
-            </a:pPr>
-            <a:r>
-              <a:rPr sz="1500" b="1" i="0">
-                <a:solidFill>
-                  <a:srgbClr val="003A70"/>
-                </a:solidFill>
-                <a:latin typeface="Calibri"/>
-              </a:rPr>
-              <a:t>●  El texto coincide palabra por palabra con el oficio real.</a:t>
+              <a:t>Genera el oficio cartera por cartera con la lista de copia; se copia o descarga para pegar en Quipux.</a:t>
             </a:r>
           </a:p>
         </p:txBody>

</xml_diff>

<commit_message>
Presentacion mas visual: slides ANTES (Excel manual) vs DESPUES (app)
- Nueva diapositiva ANTES: captura estilo Excel del reporte BCE (proceso
  manual, ~4 horas, riesgo de error).
- Nueva diapositiva DESPUES: captura de la app con todo conciliado.
- Franjas de pie de color (rojo/verde) para reforzar el contraste.
- Total 13 diapositivas; 6 con capturas reales del sistema.

Co-Authored-By: Claude Opus 4.8 <noreply@anthropic.com>
Claude-Session: https://claude.ai/code/session_01L8afBmxSSw3uGuopVyT6Ha
</commit_message>
<xml_diff>
--- a/Presentacion_Conciliacion_BCE.pptx
+++ b/Presentacion_Conciliacion_BCE.pptx
@@ -19,6 +19,8 @@
     <p:sldId id="264" r:id="rId15"/>
     <p:sldId id="265" r:id="rId16"/>
     <p:sldId id="266" r:id="rId17"/>
+    <p:sldId id="267" r:id="rId18"/>
+    <p:sldId id="268" r:id="rId19"/>
   </p:sldIdLst>
   <p:sldSz cx="9144000" cy="5143500" type="screen16x9"/>
   <p:notesSz cx="6858000" cy="9144000"/>
@@ -4129,1777 +4131,6 @@
                 </a:solidFill>
                 <a:latin typeface="Calibri"/>
               </a:rPr>
-              <a:t>Seguridad y despliegue</a:t>
-            </a:r>
-          </a:p>
-        </p:txBody>
-      </p:sp>
-      <p:sp>
-        <p:nvSpPr>
-          <p:cNvPr id="4" name="TextBox 3"/>
-          <p:cNvSpPr txBox="1"/>
-          <p:nvPr/>
-        </p:nvSpPr>
-        <p:spPr>
-          <a:xfrm>
-            <a:off x="566928" y="1417320"/>
-            <a:ext cx="7845552" cy="3177540"/>
-          </a:xfrm>
-          <a:prstGeom prst="rect">
-            <a:avLst/>
-          </a:prstGeom>
-          <a:noFill/>
-        </p:spPr>
-        <p:txBody>
-          <a:bodyPr wrap="square" anchor="t">
-            <a:spAutoFit/>
-          </a:bodyPr>
-          <a:lstStyle/>
-          <a:p>
-            <a:pPr>
-              <a:spcAft>
-                <a:spcPts val="1000"/>
-              </a:spcAft>
-            </a:pPr>
-            <a:r>
-              <a:rPr sz="1500" b="0" i="0">
-                <a:solidFill>
-                  <a:srgbClr val="58595B"/>
-                </a:solidFill>
-                <a:latin typeface="Calibri"/>
-              </a:rPr>
-              <a:t>●  Corre localmente en la PC (http://127.0.0.1:5001): los datos no salen a internet.</a:t>
-            </a:r>
-          </a:p>
-          <a:p>
-            <a:pPr>
-              <a:spcAft>
-                <a:spcPts val="1000"/>
-              </a:spcAft>
-            </a:pPr>
-            <a:r>
-              <a:rPr sz="1500" b="0" i="0">
-                <a:solidFill>
-                  <a:srgbClr val="58595B"/>
-                </a:solidFill>
-                <a:latin typeface="Calibri"/>
-              </a:rPr>
-              <a:t>●  Base de datos local para el historial de conciliaciones.</a:t>
-            </a:r>
-          </a:p>
-          <a:p>
-            <a:pPr>
-              <a:spcAft>
-                <a:spcPts val="1000"/>
-              </a:spcAft>
-            </a:pPr>
-            <a:r>
-              <a:rPr sz="1500" b="0" i="0">
-                <a:solidFill>
-                  <a:srgbClr val="58595B"/>
-                </a:solidFill>
-                <a:latin typeface="Calibri"/>
-              </a:rPr>
-              <a:t>●  Se inicia con doble clic; no requiere instalación compleja.</a:t>
-            </a:r>
-          </a:p>
-          <a:p>
-            <a:pPr>
-              <a:spcAft>
-                <a:spcPts val="1000"/>
-              </a:spcAft>
-            </a:pPr>
-            <a:r>
-              <a:rPr sz="1500" b="0" i="0">
-                <a:solidFill>
-                  <a:srgbClr val="58595B"/>
-                </a:solidFill>
-                <a:latin typeface="Calibri"/>
-              </a:rPr>
-              <a:t>●  Identidad institucional del BCE y respaldo del código versionado.</a:t>
-            </a:r>
-          </a:p>
-        </p:txBody>
-      </p:sp>
-    </p:spTree>
-  </p:cSld>
-  <p:clrMapOvr>
-    <a:masterClrMapping/>
-  </p:clrMapOvr>
-</p:sld>
-</file>
-
-<file path=ppt/slides/slide11.xml><?xml version="1.0" encoding="utf-8"?>
-<p:sld xmlns:a="http://schemas.openxmlformats.org/drawingml/2006/main" xmlns:p="http://schemas.openxmlformats.org/presentationml/2006/main" xmlns:r="http://schemas.openxmlformats.org/officeDocument/2006/relationships">
-  <p:cSld>
-    <p:spTree>
-      <p:nvGrpSpPr>
-        <p:cNvPr id="1" name=""/>
-        <p:cNvGrpSpPr/>
-        <p:nvPr/>
-      </p:nvGrpSpPr>
-      <p:grpSpPr/>
-      <p:sp>
-        <p:nvSpPr>
-          <p:cNvPr id="2" name="TextBox 1"/>
-          <p:cNvSpPr txBox="1"/>
-          <p:nvPr/>
-        </p:nvSpPr>
-        <p:spPr>
-          <a:xfrm>
-            <a:off x="566928" y="1737360"/>
-            <a:ext cx="7479792" cy="1645920"/>
-          </a:xfrm>
-          <a:prstGeom prst="rect">
-            <a:avLst/>
-          </a:prstGeom>
-          <a:noFill/>
-        </p:spPr>
-        <p:txBody>
-          <a:bodyPr wrap="square" anchor="ctr">
-            <a:spAutoFit/>
-          </a:bodyPr>
-          <a:lstStyle/>
-          <a:p>
-            <a:r>
-              <a:rPr sz="2800" b="1" i="0">
-                <a:solidFill>
-                  <a:srgbClr val="003A70"/>
-                </a:solidFill>
-                <a:latin typeface="Calibri"/>
-              </a:rPr>
-              <a:t>Conciliación exacta, rápida y trazable</a:t>
-            </a:r>
-          </a:p>
-          <a:p>
-            <a:r>
-              <a:rPr sz="1600" b="0" i="0">
-                <a:solidFill>
-                  <a:srgbClr val="58595B"/>
-                </a:solidFill>
-                <a:latin typeface="Calibri"/>
-              </a:rPr>
-              <a:t>De 4 horas mensuales a minutos, sin errores y con el oficio listo.</a:t>
-            </a:r>
-          </a:p>
-          <a:p>
-            <a:pPr>
-              <a:spcBef>
-                <a:spcPts val="1800"/>
-              </a:spcBef>
-            </a:pPr>
-            <a:r>
-              <a:rPr sz="2000" b="1" i="0">
-                <a:solidFill>
-                  <a:srgbClr val="C8961B"/>
-                </a:solidFill>
-                <a:latin typeface="Calibri"/>
-              </a:rPr>
-              <a:t>Gracias.</a:t>
-            </a:r>
-          </a:p>
-        </p:txBody>
-      </p:sp>
-    </p:spTree>
-  </p:cSld>
-  <p:clrMapOvr>
-    <a:masterClrMapping/>
-  </p:clrMapOvr>
-</p:sld>
-</file>
-
-<file path=ppt/slides/slide2.xml><?xml version="1.0" encoding="utf-8"?>
-<p:sld xmlns:a="http://schemas.openxmlformats.org/drawingml/2006/main" xmlns:p="http://schemas.openxmlformats.org/presentationml/2006/main" xmlns:r="http://schemas.openxmlformats.org/officeDocument/2006/relationships">
-  <p:cSld>
-    <p:spTree>
-      <p:nvGrpSpPr>
-        <p:cNvPr id="1" name=""/>
-        <p:cNvGrpSpPr/>
-        <p:nvPr/>
-      </p:nvGrpSpPr>
-      <p:grpSpPr/>
-      <p:sp>
-        <p:nvSpPr>
-          <p:cNvPr id="2" name="Rectangle 1"/>
-          <p:cNvSpPr/>
-          <p:nvPr/>
-        </p:nvSpPr>
-        <p:spPr>
-          <a:xfrm>
-            <a:off x="566928" y="411480"/>
-            <a:ext cx="82296" cy="457200"/>
-          </a:xfrm>
-          <a:prstGeom prst="rect">
-            <a:avLst/>
-          </a:prstGeom>
-          <a:solidFill>
-            <a:srgbClr val="C8961B"/>
-          </a:solidFill>
-          <a:ln>
-            <a:noFill/>
-          </a:ln>
-        </p:spPr>
-        <p:style>
-          <a:lnRef idx="1">
-            <a:schemeClr val="accent1"/>
-          </a:lnRef>
-          <a:fillRef idx="3">
-            <a:schemeClr val="accent1"/>
-          </a:fillRef>
-          <a:effectRef idx="2">
-            <a:schemeClr val="accent1"/>
-          </a:effectRef>
-          <a:fontRef idx="minor">
-            <a:schemeClr val="lt1"/>
-          </a:fontRef>
-        </p:style>
-        <p:txBody>
-          <a:bodyPr rtlCol="0" anchor="ctr"/>
-          <a:lstStyle/>
-          <a:p>
-            <a:pPr algn="ctr"/>
-          </a:p>
-        </p:txBody>
-      </p:sp>
-      <p:sp>
-        <p:nvSpPr>
-          <p:cNvPr id="3" name="TextBox 2"/>
-          <p:cNvSpPr txBox="1"/>
-          <p:nvPr/>
-        </p:nvSpPr>
-        <p:spPr>
-          <a:xfrm>
-            <a:off x="768096" y="365760"/>
-            <a:ext cx="7479792" cy="640080"/>
-          </a:xfrm>
-          <a:prstGeom prst="rect">
-            <a:avLst/>
-          </a:prstGeom>
-          <a:noFill/>
-        </p:spPr>
-        <p:txBody>
-          <a:bodyPr wrap="square" anchor="t">
-            <a:spAutoFit/>
-          </a:bodyPr>
-          <a:lstStyle/>
-          <a:p>
-            <a:r>
-              <a:rPr sz="2600" b="1" i="0">
-                <a:solidFill>
-                  <a:srgbClr val="003A70"/>
-                </a:solidFill>
-                <a:latin typeface="Calibri"/>
-              </a:rPr>
-              <a:t>El problema: la conciliación manual</a:t>
-            </a:r>
-          </a:p>
-        </p:txBody>
-      </p:sp>
-      <p:sp>
-        <p:nvSpPr>
-          <p:cNvPr id="4" name="TextBox 3"/>
-          <p:cNvSpPr txBox="1"/>
-          <p:nvPr/>
-        </p:nvSpPr>
-        <p:spPr>
-          <a:xfrm>
-            <a:off x="768096" y="932688"/>
-            <a:ext cx="7479792" cy="365760"/>
-          </a:xfrm>
-          <a:prstGeom prst="rect">
-            <a:avLst/>
-          </a:prstGeom>
-          <a:noFill/>
-        </p:spPr>
-        <p:txBody>
-          <a:bodyPr wrap="square" anchor="t">
-            <a:spAutoFit/>
-          </a:bodyPr>
-          <a:lstStyle/>
-          <a:p>
-            <a:r>
-              <a:rPr sz="1300" b="0" i="1">
-                <a:solidFill>
-                  <a:srgbClr val="8A8C8F"/>
-                </a:solidFill>
-                <a:latin typeface="Calibri"/>
-              </a:rPr>
-              <a:t>Situación antes de la automatización</a:t>
-            </a:r>
-          </a:p>
-        </p:txBody>
-      </p:sp>
-      <p:sp>
-        <p:nvSpPr>
-          <p:cNvPr id="5" name="TextBox 4"/>
-          <p:cNvSpPr txBox="1"/>
-          <p:nvPr/>
-        </p:nvSpPr>
-        <p:spPr>
-          <a:xfrm>
-            <a:off x="566928" y="1417320"/>
-            <a:ext cx="7845552" cy="3177540"/>
-          </a:xfrm>
-          <a:prstGeom prst="rect">
-            <a:avLst/>
-          </a:prstGeom>
-          <a:noFill/>
-        </p:spPr>
-        <p:txBody>
-          <a:bodyPr wrap="square" anchor="t">
-            <a:spAutoFit/>
-          </a:bodyPr>
-          <a:lstStyle/>
-          <a:p>
-            <a:pPr>
-              <a:spcAft>
-                <a:spcPts val="1000"/>
-              </a:spcAft>
-            </a:pPr>
-            <a:r>
-              <a:rPr sz="1500" b="0" i="0">
-                <a:solidFill>
-                  <a:srgbClr val="58595B"/>
-                </a:solidFill>
-                <a:latin typeface="Calibri"/>
-              </a:rPr>
-              <a:t>●  Cada mes se cruzan los pagos de deuda externa entre el MEF y el BCE (Agente Oficial).</a:t>
-            </a:r>
-          </a:p>
-          <a:p>
-            <a:pPr>
-              <a:spcAft>
-                <a:spcPts val="1000"/>
-              </a:spcAft>
-            </a:pPr>
-            <a:r>
-              <a:rPr sz="1500" b="0" i="0">
-                <a:solidFill>
-                  <a:srgbClr val="58595B"/>
-                </a:solidFill>
-                <a:latin typeface="Calibri"/>
-              </a:rPr>
-              <a:t>●  Se comparan 6 rubros por cada acreedor: desembolsos, amortizaciones, intereses, comisiones, condonados e interés por mora.</a:t>
-            </a:r>
-          </a:p>
-          <a:p>
-            <a:pPr>
-              <a:spcAft>
-                <a:spcPts val="1000"/>
-              </a:spcAft>
-            </a:pPr>
-            <a:r>
-              <a:rPr sz="1500" b="0" i="0">
-                <a:solidFill>
-                  <a:srgbClr val="58595B"/>
-                </a:solidFill>
-                <a:latin typeface="Calibri"/>
-              </a:rPr>
-              <a:t>●  Revisión préstamo por préstamo en archivos Excel extensos, sumando y cuadrando valor por valor, uno a uno.</a:t>
-            </a:r>
-          </a:p>
-          <a:p>
-            <a:pPr>
-              <a:spcAft>
-                <a:spcPts val="1000"/>
-              </a:spcAft>
-            </a:pPr>
-            <a:r>
-              <a:rPr sz="1500" b="1" i="0">
-                <a:solidFill>
-                  <a:srgbClr val="C0392B"/>
-                </a:solidFill>
-                <a:latin typeface="Calibri"/>
-              </a:rPr>
-              <a:t>●  Toma en promedio 4 horas mensuales, con alto riesgo de error humano.</a:t>
-            </a:r>
-          </a:p>
-          <a:p>
-            <a:pPr>
-              <a:spcAft>
-                <a:spcPts val="1000"/>
-              </a:spcAft>
-            </a:pPr>
-            <a:r>
-              <a:rPr sz="1500" b="0" i="0">
-                <a:solidFill>
-                  <a:srgbClr val="58595B"/>
-                </a:solidFill>
-                <a:latin typeface="Calibri"/>
-              </a:rPr>
-              <a:t>●  Además, había que redactar manualmente el oficio de respuesta (Quipux).</a:t>
-            </a:r>
-          </a:p>
-        </p:txBody>
-      </p:sp>
-    </p:spTree>
-  </p:cSld>
-  <p:clrMapOvr>
-    <a:masterClrMapping/>
-  </p:clrMapOvr>
-</p:sld>
-</file>
-
-<file path=ppt/slides/slide3.xml><?xml version="1.0" encoding="utf-8"?>
-<p:sld xmlns:a="http://schemas.openxmlformats.org/drawingml/2006/main" xmlns:p="http://schemas.openxmlformats.org/presentationml/2006/main" xmlns:r="http://schemas.openxmlformats.org/officeDocument/2006/relationships">
-  <p:cSld>
-    <p:spTree>
-      <p:nvGrpSpPr>
-        <p:cNvPr id="1" name=""/>
-        <p:cNvGrpSpPr/>
-        <p:nvPr/>
-      </p:nvGrpSpPr>
-      <p:grpSpPr/>
-      <p:sp>
-        <p:nvSpPr>
-          <p:cNvPr id="2" name="Rectangle 1"/>
-          <p:cNvSpPr/>
-          <p:nvPr/>
-        </p:nvSpPr>
-        <p:spPr>
-          <a:xfrm>
-            <a:off x="566928" y="411480"/>
-            <a:ext cx="82296" cy="457200"/>
-          </a:xfrm>
-          <a:prstGeom prst="rect">
-            <a:avLst/>
-          </a:prstGeom>
-          <a:solidFill>
-            <a:srgbClr val="C8961B"/>
-          </a:solidFill>
-          <a:ln>
-            <a:noFill/>
-          </a:ln>
-        </p:spPr>
-        <p:style>
-          <a:lnRef idx="1">
-            <a:schemeClr val="accent1"/>
-          </a:lnRef>
-          <a:fillRef idx="3">
-            <a:schemeClr val="accent1"/>
-          </a:fillRef>
-          <a:effectRef idx="2">
-            <a:schemeClr val="accent1"/>
-          </a:effectRef>
-          <a:fontRef idx="minor">
-            <a:schemeClr val="lt1"/>
-          </a:fontRef>
-        </p:style>
-        <p:txBody>
-          <a:bodyPr rtlCol="0" anchor="ctr"/>
-          <a:lstStyle/>
-          <a:p>
-            <a:pPr algn="ctr"/>
-          </a:p>
-        </p:txBody>
-      </p:sp>
-      <p:sp>
-        <p:nvSpPr>
-          <p:cNvPr id="3" name="TextBox 2"/>
-          <p:cNvSpPr txBox="1"/>
-          <p:nvPr/>
-        </p:nvSpPr>
-        <p:spPr>
-          <a:xfrm>
-            <a:off x="768096" y="365760"/>
-            <a:ext cx="7479792" cy="640080"/>
-          </a:xfrm>
-          <a:prstGeom prst="rect">
-            <a:avLst/>
-          </a:prstGeom>
-          <a:noFill/>
-        </p:spPr>
-        <p:txBody>
-          <a:bodyPr wrap="square" anchor="t">
-            <a:spAutoFit/>
-          </a:bodyPr>
-          <a:lstStyle/>
-          <a:p>
-            <a:r>
-              <a:rPr sz="2600" b="1" i="0">
-                <a:solidFill>
-                  <a:srgbClr val="003A70"/>
-                </a:solidFill>
-                <a:latin typeface="Calibri"/>
-              </a:rPr>
-              <a:t>El impacto conseguido</a:t>
-            </a:r>
-          </a:p>
-        </p:txBody>
-      </p:sp>
-      <p:sp>
-        <p:nvSpPr>
-          <p:cNvPr id="4" name="Rounded Rectangle 3"/>
-          <p:cNvSpPr/>
-          <p:nvPr/>
-        </p:nvSpPr>
-        <p:spPr>
-          <a:xfrm>
-            <a:off x="566928" y="1554480"/>
-            <a:ext cx="3566160" cy="2286000"/>
-          </a:xfrm>
-          <a:prstGeom prst="roundRect">
-            <a:avLst/>
-          </a:prstGeom>
-          <a:solidFill>
-            <a:srgbClr val="FFFFFF"/>
-          </a:solidFill>
-          <a:ln w="19050">
-            <a:solidFill>
-              <a:srgbClr val="C0392B"/>
-            </a:solidFill>
-          </a:ln>
-          <a:effectLst/>
-        </p:spPr>
-        <p:style>
-          <a:lnRef idx="1">
-            <a:schemeClr val="accent1"/>
-          </a:lnRef>
-          <a:fillRef idx="3">
-            <a:schemeClr val="accent1"/>
-          </a:fillRef>
-          <a:effectRef idx="2">
-            <a:schemeClr val="accent1"/>
-          </a:effectRef>
-          <a:fontRef idx="minor">
-            <a:schemeClr val="lt1"/>
-          </a:fontRef>
-        </p:style>
-        <p:txBody>
-          <a:bodyPr rtlCol="0" anchor="ctr" wrap="square"/>
-          <a:lstStyle/>
-          <a:p>
-            <a:pPr algn="ctr"/>
-            <a:r>
-              <a:rPr sz="1500" b="1" i="0">
-                <a:solidFill>
-                  <a:srgbClr val="58595B"/>
-                </a:solidFill>
-                <a:latin typeface="Calibri"/>
-              </a:rPr>
-              <a:t>ANTES (manual)</a:t>
-            </a:r>
-          </a:p>
-          <a:p>
-            <a:pPr algn="ctr"/>
-            <a:r>
-              <a:rPr sz="4400" b="1" i="0">
-                <a:solidFill>
-                  <a:srgbClr val="C0392B"/>
-                </a:solidFill>
-                <a:latin typeface="Calibri"/>
-              </a:rPr>
-              <a:t>≈ 4 horas</a:t>
-            </a:r>
-          </a:p>
-          <a:p>
-            <a:pPr algn="ctr"/>
-            <a:r>
-              <a:rPr sz="1300" b="0" i="0">
-                <a:solidFill>
-                  <a:srgbClr val="8A8C8F"/>
-                </a:solidFill>
-                <a:latin typeface="Calibri"/>
-              </a:rPr>
-              <a:t>cada mes, revisando valor por valor</a:t>
-            </a:r>
-          </a:p>
-        </p:txBody>
-      </p:sp>
-      <p:sp>
-        <p:nvSpPr>
-          <p:cNvPr id="5" name="Rounded Rectangle 4"/>
-          <p:cNvSpPr/>
-          <p:nvPr/>
-        </p:nvSpPr>
-        <p:spPr>
-          <a:xfrm>
-            <a:off x="4498848" y="1554480"/>
-            <a:ext cx="3566160" cy="2286000"/>
-          </a:xfrm>
-          <a:prstGeom prst="roundRect">
-            <a:avLst/>
-          </a:prstGeom>
-          <a:solidFill>
-            <a:srgbClr val="FFFFFF"/>
-          </a:solidFill>
-          <a:ln w="19050">
-            <a:solidFill>
-              <a:srgbClr val="1E824C"/>
-            </a:solidFill>
-          </a:ln>
-          <a:effectLst/>
-        </p:spPr>
-        <p:style>
-          <a:lnRef idx="1">
-            <a:schemeClr val="accent1"/>
-          </a:lnRef>
-          <a:fillRef idx="3">
-            <a:schemeClr val="accent1"/>
-          </a:fillRef>
-          <a:effectRef idx="2">
-            <a:schemeClr val="accent1"/>
-          </a:effectRef>
-          <a:fontRef idx="minor">
-            <a:schemeClr val="lt1"/>
-          </a:fontRef>
-        </p:style>
-        <p:txBody>
-          <a:bodyPr rtlCol="0" anchor="ctr" wrap="square"/>
-          <a:lstStyle/>
-          <a:p>
-            <a:pPr algn="ctr"/>
-            <a:r>
-              <a:rPr sz="1500" b="1" i="0">
-                <a:solidFill>
-                  <a:srgbClr val="58595B"/>
-                </a:solidFill>
-                <a:latin typeface="Calibri"/>
-              </a:rPr>
-              <a:t>AHORA (automatizado)</a:t>
-            </a:r>
-          </a:p>
-          <a:p>
-            <a:pPr algn="ctr"/>
-            <a:r>
-              <a:rPr sz="4400" b="1" i="0">
-                <a:solidFill>
-                  <a:srgbClr val="1E824C"/>
-                </a:solidFill>
-                <a:latin typeface="Calibri"/>
-              </a:rPr>
-              <a:t>Minutos</a:t>
-            </a:r>
-          </a:p>
-          <a:p>
-            <a:pPr algn="ctr"/>
-            <a:r>
-              <a:rPr sz="1300" b="0" i="0">
-                <a:solidFill>
-                  <a:srgbClr val="8A8C8F"/>
-                </a:solidFill>
-                <a:latin typeface="Calibri"/>
-              </a:rPr>
-              <a:t>cruce y verificación automáticos</a:t>
-            </a:r>
-          </a:p>
-        </p:txBody>
-      </p:sp>
-      <p:sp>
-        <p:nvSpPr>
-          <p:cNvPr id="6" name="TextBox 5"/>
-          <p:cNvSpPr txBox="1"/>
-          <p:nvPr/>
-        </p:nvSpPr>
-        <p:spPr>
-          <a:xfrm>
-            <a:off x="566928" y="4069080"/>
-            <a:ext cx="7845552" cy="640080"/>
-          </a:xfrm>
-          <a:prstGeom prst="rect">
-            <a:avLst/>
-          </a:prstGeom>
-          <a:noFill/>
-        </p:spPr>
-        <p:txBody>
-          <a:bodyPr wrap="square" anchor="t">
-            <a:spAutoFit/>
-          </a:bodyPr>
-          <a:lstStyle/>
-          <a:p>
-            <a:pPr algn="ctr"/>
-            <a:r>
-              <a:rPr sz="1300" b="1" i="0">
-                <a:solidFill>
-                  <a:srgbClr val="003A70"/>
-                </a:solidFill>
-                <a:latin typeface="Calibri"/>
-              </a:rPr>
-              <a:t>Cálculo exacto al centavo · identifica el préstamo que no cuadra · genera el oficio de respuesta</a:t>
-            </a:r>
-          </a:p>
-        </p:txBody>
-      </p:sp>
-    </p:spTree>
-  </p:cSld>
-  <p:clrMapOvr>
-    <a:masterClrMapping/>
-  </p:clrMapOvr>
-</p:sld>
-</file>
-
-<file path=ppt/slides/slide4.xml><?xml version="1.0" encoding="utf-8"?>
-<p:sld xmlns:a="http://schemas.openxmlformats.org/drawingml/2006/main" xmlns:p="http://schemas.openxmlformats.org/presentationml/2006/main" xmlns:r="http://schemas.openxmlformats.org/officeDocument/2006/relationships">
-  <p:cSld>
-    <p:spTree>
-      <p:nvGrpSpPr>
-        <p:cNvPr id="1" name=""/>
-        <p:cNvGrpSpPr/>
-        <p:nvPr/>
-      </p:nvGrpSpPr>
-      <p:grpSpPr/>
-      <p:sp>
-        <p:nvSpPr>
-          <p:cNvPr id="2" name="Rectangle 1"/>
-          <p:cNvSpPr/>
-          <p:nvPr/>
-        </p:nvSpPr>
-        <p:spPr>
-          <a:xfrm>
-            <a:off x="566928" y="411480"/>
-            <a:ext cx="82296" cy="457200"/>
-          </a:xfrm>
-          <a:prstGeom prst="rect">
-            <a:avLst/>
-          </a:prstGeom>
-          <a:solidFill>
-            <a:srgbClr val="C8961B"/>
-          </a:solidFill>
-          <a:ln>
-            <a:noFill/>
-          </a:ln>
-        </p:spPr>
-        <p:style>
-          <a:lnRef idx="1">
-            <a:schemeClr val="accent1"/>
-          </a:lnRef>
-          <a:fillRef idx="3">
-            <a:schemeClr val="accent1"/>
-          </a:fillRef>
-          <a:effectRef idx="2">
-            <a:schemeClr val="accent1"/>
-          </a:effectRef>
-          <a:fontRef idx="minor">
-            <a:schemeClr val="lt1"/>
-          </a:fontRef>
-        </p:style>
-        <p:txBody>
-          <a:bodyPr rtlCol="0" anchor="ctr"/>
-          <a:lstStyle/>
-          <a:p>
-            <a:pPr algn="ctr"/>
-          </a:p>
-        </p:txBody>
-      </p:sp>
-      <p:sp>
-        <p:nvSpPr>
-          <p:cNvPr id="3" name="TextBox 2"/>
-          <p:cNvSpPr txBox="1"/>
-          <p:nvPr/>
-        </p:nvSpPr>
-        <p:spPr>
-          <a:xfrm>
-            <a:off x="768096" y="365760"/>
-            <a:ext cx="7479792" cy="640080"/>
-          </a:xfrm>
-          <a:prstGeom prst="rect">
-            <a:avLst/>
-          </a:prstGeom>
-          <a:noFill/>
-        </p:spPr>
-        <p:txBody>
-          <a:bodyPr wrap="square" anchor="t">
-            <a:spAutoFit/>
-          </a:bodyPr>
-          <a:lstStyle/>
-          <a:p>
-            <a:r>
-              <a:rPr sz="2600" b="1" i="0">
-                <a:solidFill>
-                  <a:srgbClr val="003A70"/>
-                </a:solidFill>
-                <a:latin typeface="Calibri"/>
-              </a:rPr>
-              <a:t>La solución: un sistema en 4 pasos</a:t>
-            </a:r>
-          </a:p>
-        </p:txBody>
-      </p:sp>
-      <p:sp>
-        <p:nvSpPr>
-          <p:cNvPr id="4" name="Rounded Rectangle 3"/>
-          <p:cNvSpPr/>
-          <p:nvPr/>
-        </p:nvSpPr>
-        <p:spPr>
-          <a:xfrm>
-            <a:off x="566928" y="1645920"/>
-            <a:ext cx="1783080" cy="2103120"/>
-          </a:xfrm>
-          <a:prstGeom prst="roundRect">
-            <a:avLst/>
-          </a:prstGeom>
-          <a:solidFill>
-            <a:srgbClr val="F3F6FB"/>
-          </a:solidFill>
-          <a:ln w="12700">
-            <a:solidFill>
-              <a:srgbClr val="0072CE"/>
-            </a:solidFill>
-          </a:ln>
-          <a:effectLst/>
-        </p:spPr>
-        <p:style>
-          <a:lnRef idx="1">
-            <a:schemeClr val="accent1"/>
-          </a:lnRef>
-          <a:fillRef idx="3">
-            <a:schemeClr val="accent1"/>
-          </a:fillRef>
-          <a:effectRef idx="2">
-            <a:schemeClr val="accent1"/>
-          </a:effectRef>
-          <a:fontRef idx="minor">
-            <a:schemeClr val="lt1"/>
-          </a:fontRef>
-        </p:style>
-        <p:txBody>
-          <a:bodyPr rtlCol="0" anchor="t" wrap="square"/>
-          <a:lstStyle/>
-          <a:p>
-            <a:pPr algn="ctr"/>
-            <a:r>
-              <a:rPr sz="3000" b="1" i="0">
-                <a:solidFill>
-                  <a:srgbClr val="C8961B"/>
-                </a:solidFill>
-                <a:latin typeface="Calibri"/>
-              </a:rPr>
-              <a:t>I</a:t>
-            </a:r>
-          </a:p>
-          <a:p>
-            <a:pPr algn="ctr"/>
-            <a:r>
-              <a:rPr sz="1350" b="1" i="0">
-                <a:solidFill>
-                  <a:srgbClr val="003A70"/>
-                </a:solidFill>
-                <a:latin typeface="Calibri"/>
-              </a:rPr>
-              <a:t>Recepción de Reportes</a:t>
-            </a:r>
-          </a:p>
-          <a:p>
-            <a:pPr algn="ctr"/>
-            <a:r>
-              <a:rPr sz="1150" b="0" i="0">
-                <a:solidFill>
-                  <a:srgbClr val="58595B"/>
-                </a:solidFill>
-                <a:latin typeface="Calibri"/>
-              </a:rPr>
-              <a:t>Cargar MEF + BCE (arrastrar)</a:t>
-            </a:r>
-          </a:p>
-        </p:txBody>
-      </p:sp>
-      <p:sp>
-        <p:nvSpPr>
-          <p:cNvPr id="5" name="Rounded Rectangle 4"/>
-          <p:cNvSpPr/>
-          <p:nvPr/>
-        </p:nvSpPr>
-        <p:spPr>
-          <a:xfrm>
-            <a:off x="2505456" y="1645920"/>
-            <a:ext cx="1783080" cy="2103120"/>
-          </a:xfrm>
-          <a:prstGeom prst="roundRect">
-            <a:avLst/>
-          </a:prstGeom>
-          <a:solidFill>
-            <a:srgbClr val="F3F6FB"/>
-          </a:solidFill>
-          <a:ln w="12700">
-            <a:solidFill>
-              <a:srgbClr val="0072CE"/>
-            </a:solidFill>
-          </a:ln>
-          <a:effectLst/>
-        </p:spPr>
-        <p:style>
-          <a:lnRef idx="1">
-            <a:schemeClr val="accent1"/>
-          </a:lnRef>
-          <a:fillRef idx="3">
-            <a:schemeClr val="accent1"/>
-          </a:fillRef>
-          <a:effectRef idx="2">
-            <a:schemeClr val="accent1"/>
-          </a:effectRef>
-          <a:fontRef idx="minor">
-            <a:schemeClr val="lt1"/>
-          </a:fontRef>
-        </p:style>
-        <p:txBody>
-          <a:bodyPr rtlCol="0" anchor="t" wrap="square"/>
-          <a:lstStyle/>
-          <a:p>
-            <a:pPr algn="ctr"/>
-            <a:r>
-              <a:rPr sz="3000" b="1" i="0">
-                <a:solidFill>
-                  <a:srgbClr val="C8961B"/>
-                </a:solidFill>
-                <a:latin typeface="Calibri"/>
-              </a:rPr>
-              <a:t>II</a:t>
-            </a:r>
-          </a:p>
-          <a:p>
-            <a:pPr algn="ctr"/>
-            <a:r>
-              <a:rPr sz="1350" b="1" i="0">
-                <a:solidFill>
-                  <a:srgbClr val="003A70"/>
-                </a:solidFill>
-                <a:latin typeface="Calibri"/>
-              </a:rPr>
-              <a:t>Conciliación de Carteras</a:t>
-            </a:r>
-          </a:p>
-          <a:p>
-            <a:pPr algn="ctr"/>
-            <a:r>
-              <a:rPr sz="1150" b="0" i="0">
-                <a:solidFill>
-                  <a:srgbClr val="58595B"/>
-                </a:solidFill>
-                <a:latin typeface="Calibri"/>
-              </a:rPr>
-              <a:t>Matriz con semáforo y total</a:t>
-            </a:r>
-          </a:p>
-        </p:txBody>
-      </p:sp>
-      <p:sp>
-        <p:nvSpPr>
-          <p:cNvPr id="6" name="Rounded Rectangle 5"/>
-          <p:cNvSpPr/>
-          <p:nvPr/>
-        </p:nvSpPr>
-        <p:spPr>
-          <a:xfrm>
-            <a:off x="4443984" y="1645920"/>
-            <a:ext cx="1783080" cy="2103120"/>
-          </a:xfrm>
-          <a:prstGeom prst="roundRect">
-            <a:avLst/>
-          </a:prstGeom>
-          <a:solidFill>
-            <a:srgbClr val="F3F6FB"/>
-          </a:solidFill>
-          <a:ln w="12700">
-            <a:solidFill>
-              <a:srgbClr val="0072CE"/>
-            </a:solidFill>
-          </a:ln>
-          <a:effectLst/>
-        </p:spPr>
-        <p:style>
-          <a:lnRef idx="1">
-            <a:schemeClr val="accent1"/>
-          </a:lnRef>
-          <a:fillRef idx="3">
-            <a:schemeClr val="accent1"/>
-          </a:fillRef>
-          <a:effectRef idx="2">
-            <a:schemeClr val="accent1"/>
-          </a:effectRef>
-          <a:fontRef idx="minor">
-            <a:schemeClr val="lt1"/>
-          </a:fontRef>
-        </p:style>
-        <p:txBody>
-          <a:bodyPr rtlCol="0" anchor="t" wrap="square"/>
-          <a:lstStyle/>
-          <a:p>
-            <a:pPr algn="ctr"/>
-            <a:r>
-              <a:rPr sz="3000" b="1" i="0">
-                <a:solidFill>
-                  <a:srgbClr val="C8961B"/>
-                </a:solidFill>
-                <a:latin typeface="Calibri"/>
-              </a:rPr>
-              <a:t>III</a:t>
-            </a:r>
-          </a:p>
-          <a:p>
-            <a:pPr algn="ctr"/>
-            <a:r>
-              <a:rPr sz="1350" b="1" i="0">
-                <a:solidFill>
-                  <a:srgbClr val="003A70"/>
-                </a:solidFill>
-                <a:latin typeface="Calibri"/>
-              </a:rPr>
-              <a:t>Gestión de Observaciones</a:t>
-            </a:r>
-          </a:p>
-          <a:p>
-            <a:pPr algn="ctr"/>
-            <a:r>
-              <a:rPr sz="1150" b="0" i="0">
-                <a:solidFill>
-                  <a:srgbClr val="58595B"/>
-                </a:solidFill>
-                <a:latin typeface="Calibri"/>
-              </a:rPr>
-              <a:t>Resolver lo que no cuadra</a:t>
-            </a:r>
-          </a:p>
-        </p:txBody>
-      </p:sp>
-      <p:sp>
-        <p:nvSpPr>
-          <p:cNvPr id="7" name="Rounded Rectangle 6"/>
-          <p:cNvSpPr/>
-          <p:nvPr/>
-        </p:nvSpPr>
-        <p:spPr>
-          <a:xfrm>
-            <a:off x="6382512" y="1645920"/>
-            <a:ext cx="1783080" cy="2103120"/>
-          </a:xfrm>
-          <a:prstGeom prst="roundRect">
-            <a:avLst/>
-          </a:prstGeom>
-          <a:solidFill>
-            <a:srgbClr val="F3F6FB"/>
-          </a:solidFill>
-          <a:ln w="12700">
-            <a:solidFill>
-              <a:srgbClr val="0072CE"/>
-            </a:solidFill>
-          </a:ln>
-          <a:effectLst/>
-        </p:spPr>
-        <p:style>
-          <a:lnRef idx="1">
-            <a:schemeClr val="accent1"/>
-          </a:lnRef>
-          <a:fillRef idx="3">
-            <a:schemeClr val="accent1"/>
-          </a:fillRef>
-          <a:effectRef idx="2">
-            <a:schemeClr val="accent1"/>
-          </a:effectRef>
-          <a:fontRef idx="minor">
-            <a:schemeClr val="lt1"/>
-          </a:fontRef>
-        </p:style>
-        <p:txBody>
-          <a:bodyPr rtlCol="0" anchor="t" wrap="square"/>
-          <a:lstStyle/>
-          <a:p>
-            <a:pPr algn="ctr"/>
-            <a:r>
-              <a:rPr sz="3000" b="1" i="0">
-                <a:solidFill>
-                  <a:srgbClr val="C8961B"/>
-                </a:solidFill>
-                <a:latin typeface="Calibri"/>
-              </a:rPr>
-              <a:t>IV</a:t>
-            </a:r>
-          </a:p>
-          <a:p>
-            <a:pPr algn="ctr"/>
-            <a:r>
-              <a:rPr sz="1350" b="1" i="0">
-                <a:solidFill>
-                  <a:srgbClr val="003A70"/>
-                </a:solidFill>
-                <a:latin typeface="Calibri"/>
-              </a:rPr>
-              <a:t>Emisión del Oficio</a:t>
-            </a:r>
-          </a:p>
-          <a:p>
-            <a:pPr algn="ctr"/>
-            <a:r>
-              <a:rPr sz="1150" b="0" i="0">
-                <a:solidFill>
-                  <a:srgbClr val="58595B"/>
-                </a:solidFill>
-                <a:latin typeface="Calibri"/>
-              </a:rPr>
-              <a:t>Generar el Quipux de respuesta</a:t>
-            </a:r>
-          </a:p>
-        </p:txBody>
-      </p:sp>
-    </p:spTree>
-  </p:cSld>
-  <p:clrMapOvr>
-    <a:masterClrMapping/>
-  </p:clrMapOvr>
-</p:sld>
-</file>
-
-<file path=ppt/slides/slide5.xml><?xml version="1.0" encoding="utf-8"?>
-<p:sld xmlns:a="http://schemas.openxmlformats.org/drawingml/2006/main" xmlns:p="http://schemas.openxmlformats.org/presentationml/2006/main" xmlns:r="http://schemas.openxmlformats.org/officeDocument/2006/relationships">
-  <p:cSld>
-    <p:spTree>
-      <p:nvGrpSpPr>
-        <p:cNvPr id="1" name=""/>
-        <p:cNvGrpSpPr/>
-        <p:nvPr/>
-      </p:nvGrpSpPr>
-      <p:grpSpPr/>
-      <p:sp>
-        <p:nvSpPr>
-          <p:cNvPr id="2" name="Rectangle 1"/>
-          <p:cNvSpPr/>
-          <p:nvPr/>
-        </p:nvSpPr>
-        <p:spPr>
-          <a:xfrm>
-            <a:off x="566928" y="411480"/>
-            <a:ext cx="82296" cy="457200"/>
-          </a:xfrm>
-          <a:prstGeom prst="rect">
-            <a:avLst/>
-          </a:prstGeom>
-          <a:solidFill>
-            <a:srgbClr val="C8961B"/>
-          </a:solidFill>
-          <a:ln>
-            <a:noFill/>
-          </a:ln>
-        </p:spPr>
-        <p:style>
-          <a:lnRef idx="1">
-            <a:schemeClr val="accent1"/>
-          </a:lnRef>
-          <a:fillRef idx="3">
-            <a:schemeClr val="accent1"/>
-          </a:fillRef>
-          <a:effectRef idx="2">
-            <a:schemeClr val="accent1"/>
-          </a:effectRef>
-          <a:fontRef idx="minor">
-            <a:schemeClr val="lt1"/>
-          </a:fontRef>
-        </p:style>
-        <p:txBody>
-          <a:bodyPr rtlCol="0" anchor="ctr"/>
-          <a:lstStyle/>
-          <a:p>
-            <a:pPr algn="ctr"/>
-          </a:p>
-        </p:txBody>
-      </p:sp>
-      <p:sp>
-        <p:nvSpPr>
-          <p:cNvPr id="3" name="TextBox 2"/>
-          <p:cNvSpPr txBox="1"/>
-          <p:nvPr/>
-        </p:nvSpPr>
-        <p:spPr>
-          <a:xfrm>
-            <a:off x="768096" y="365760"/>
-            <a:ext cx="7479792" cy="640080"/>
-          </a:xfrm>
-          <a:prstGeom prst="rect">
-            <a:avLst/>
-          </a:prstGeom>
-          <a:noFill/>
-        </p:spPr>
-        <p:txBody>
-          <a:bodyPr wrap="square" anchor="t">
-            <a:spAutoFit/>
-          </a:bodyPr>
-          <a:lstStyle/>
-          <a:p>
-            <a:r>
-              <a:rPr sz="2600" b="1" i="0">
-                <a:solidFill>
-                  <a:srgbClr val="003A70"/>
-                </a:solidFill>
-                <a:latin typeface="Calibri"/>
-              </a:rPr>
-              <a:t>Paso I · Recepción de Reportes</a:t>
-            </a:r>
-          </a:p>
-        </p:txBody>
-      </p:sp>
-      <p:sp>
-        <p:nvSpPr>
-          <p:cNvPr id="4" name="TextBox 3"/>
-          <p:cNvSpPr txBox="1"/>
-          <p:nvPr/>
-        </p:nvSpPr>
-        <p:spPr>
-          <a:xfrm>
-            <a:off x="768096" y="932688"/>
-            <a:ext cx="7479792" cy="365760"/>
-          </a:xfrm>
-          <a:prstGeom prst="rect">
-            <a:avLst/>
-          </a:prstGeom>
-          <a:noFill/>
-        </p:spPr>
-        <p:txBody>
-          <a:bodyPr wrap="square" anchor="t">
-            <a:spAutoFit/>
-          </a:bodyPr>
-          <a:lstStyle/>
-          <a:p>
-            <a:r>
-              <a:rPr sz="1300" b="0" i="1">
-                <a:solidFill>
-                  <a:srgbClr val="8A8C8F"/>
-                </a:solidFill>
-                <a:latin typeface="Calibri"/>
-              </a:rPr>
-              <a:t>Carga inteligente</a:t>
-            </a:r>
-          </a:p>
-        </p:txBody>
-      </p:sp>
-      <p:pic>
-        <p:nvPicPr>
-          <p:cNvPr id="5" name="Picture 4" descr="s1_carga.png"/>
-          <p:cNvPicPr>
-            <a:picLocks noChangeAspect="1"/>
-          </p:cNvPicPr>
-          <p:nvPr/>
-        </p:nvPicPr>
-        <p:blipFill>
-          <a:blip r:embed="rId2"/>
-          <a:stretch>
-            <a:fillRect/>
-          </a:stretch>
-        </p:blipFill>
-        <p:spPr>
-          <a:xfrm>
-            <a:off x="1394460" y="1097280"/>
-            <a:ext cx="6355080" cy="3575304"/>
-          </a:xfrm>
-          <a:prstGeom prst="rect">
-            <a:avLst/>
-          </a:prstGeom>
-          <a:ln w="9525">
-            <a:solidFill>
-              <a:srgbClr val="0072CE"/>
-            </a:solidFill>
-          </a:ln>
-        </p:spPr>
-      </p:pic>
-      <p:sp>
-        <p:nvSpPr>
-          <p:cNvPr id="6" name="TextBox 5"/>
-          <p:cNvSpPr txBox="1"/>
-          <p:nvPr/>
-        </p:nvSpPr>
-        <p:spPr>
-          <a:xfrm>
-            <a:off x="548640" y="4736592"/>
-            <a:ext cx="8046720" cy="320040"/>
-          </a:xfrm>
-          <a:prstGeom prst="rect">
-            <a:avLst/>
-          </a:prstGeom>
-          <a:noFill/>
-        </p:spPr>
-        <p:txBody>
-          <a:bodyPr wrap="square" anchor="t">
-            <a:spAutoFit/>
-          </a:bodyPr>
-          <a:lstStyle/>
-          <a:p>
-            <a:pPr algn="ctr"/>
-            <a:r>
-              <a:rPr sz="1100" b="0" i="1">
-                <a:solidFill>
-                  <a:srgbClr val="8A8C8F"/>
-                </a:solidFill>
-                <a:latin typeface="Calibri"/>
-              </a:rPr>
-              <a:t>Una sola zona: se arrastran los dos reportes (MEF y BCE); el período se detecta automáticamente.</a:t>
-            </a:r>
-          </a:p>
-        </p:txBody>
-      </p:sp>
-    </p:spTree>
-  </p:cSld>
-  <p:clrMapOvr>
-    <a:masterClrMapping/>
-  </p:clrMapOvr>
-</p:sld>
-</file>
-
-<file path=ppt/slides/slide6.xml><?xml version="1.0" encoding="utf-8"?>
-<p:sld xmlns:a="http://schemas.openxmlformats.org/drawingml/2006/main" xmlns:p="http://schemas.openxmlformats.org/presentationml/2006/main" xmlns:r="http://schemas.openxmlformats.org/officeDocument/2006/relationships">
-  <p:cSld>
-    <p:spTree>
-      <p:nvGrpSpPr>
-        <p:cNvPr id="1" name=""/>
-        <p:cNvGrpSpPr/>
-        <p:nvPr/>
-      </p:nvGrpSpPr>
-      <p:grpSpPr/>
-      <p:sp>
-        <p:nvSpPr>
-          <p:cNvPr id="2" name="Rectangle 1"/>
-          <p:cNvSpPr/>
-          <p:nvPr/>
-        </p:nvSpPr>
-        <p:spPr>
-          <a:xfrm>
-            <a:off x="566928" y="411480"/>
-            <a:ext cx="82296" cy="457200"/>
-          </a:xfrm>
-          <a:prstGeom prst="rect">
-            <a:avLst/>
-          </a:prstGeom>
-          <a:solidFill>
-            <a:srgbClr val="C8961B"/>
-          </a:solidFill>
-          <a:ln>
-            <a:noFill/>
-          </a:ln>
-        </p:spPr>
-        <p:style>
-          <a:lnRef idx="1">
-            <a:schemeClr val="accent1"/>
-          </a:lnRef>
-          <a:fillRef idx="3">
-            <a:schemeClr val="accent1"/>
-          </a:fillRef>
-          <a:effectRef idx="2">
-            <a:schemeClr val="accent1"/>
-          </a:effectRef>
-          <a:fontRef idx="minor">
-            <a:schemeClr val="lt1"/>
-          </a:fontRef>
-        </p:style>
-        <p:txBody>
-          <a:bodyPr rtlCol="0" anchor="ctr"/>
-          <a:lstStyle/>
-          <a:p>
-            <a:pPr algn="ctr"/>
-          </a:p>
-        </p:txBody>
-      </p:sp>
-      <p:sp>
-        <p:nvSpPr>
-          <p:cNvPr id="3" name="TextBox 2"/>
-          <p:cNvSpPr txBox="1"/>
-          <p:nvPr/>
-        </p:nvSpPr>
-        <p:spPr>
-          <a:xfrm>
-            <a:off x="768096" y="365760"/>
-            <a:ext cx="7479792" cy="640080"/>
-          </a:xfrm>
-          <a:prstGeom prst="rect">
-            <a:avLst/>
-          </a:prstGeom>
-          <a:noFill/>
-        </p:spPr>
-        <p:txBody>
-          <a:bodyPr wrap="square" anchor="t">
-            <a:spAutoFit/>
-          </a:bodyPr>
-          <a:lstStyle/>
-          <a:p>
-            <a:r>
-              <a:rPr sz="2600" b="1" i="0">
-                <a:solidFill>
-                  <a:srgbClr val="003A70"/>
-                </a:solidFill>
-                <a:latin typeface="Calibri"/>
-              </a:rPr>
-              <a:t>Paso II · Conciliación de Carteras</a:t>
-            </a:r>
-          </a:p>
-        </p:txBody>
-      </p:sp>
-      <p:sp>
-        <p:nvSpPr>
-          <p:cNvPr id="4" name="TextBox 3"/>
-          <p:cNvSpPr txBox="1"/>
-          <p:nvPr/>
-        </p:nvSpPr>
-        <p:spPr>
-          <a:xfrm>
-            <a:off x="768096" y="932688"/>
-            <a:ext cx="7479792" cy="365760"/>
-          </a:xfrm>
-          <a:prstGeom prst="rect">
-            <a:avLst/>
-          </a:prstGeom>
-          <a:noFill/>
-        </p:spPr>
-        <p:txBody>
-          <a:bodyPr wrap="square" anchor="t">
-            <a:spAutoFit/>
-          </a:bodyPr>
-          <a:lstStyle/>
-          <a:p>
-            <a:r>
-              <a:rPr sz="1300" b="0" i="1">
-                <a:solidFill>
-                  <a:srgbClr val="8A8C8F"/>
-                </a:solidFill>
-                <a:latin typeface="Calibri"/>
-              </a:rPr>
-              <a:t>Matriz con semáforo y total general</a:t>
-            </a:r>
-          </a:p>
-        </p:txBody>
-      </p:sp>
-      <p:pic>
-        <p:nvPicPr>
-          <p:cNvPr id="5" name="Picture 4" descr="s2_resultados.png"/>
-          <p:cNvPicPr>
-            <a:picLocks noChangeAspect="1"/>
-          </p:cNvPicPr>
-          <p:nvPr/>
-        </p:nvPicPr>
-        <p:blipFill>
-          <a:blip r:embed="rId2"/>
-          <a:stretch>
-            <a:fillRect/>
-          </a:stretch>
-        </p:blipFill>
-        <p:spPr>
-          <a:xfrm>
-            <a:off x="1394460" y="1097280"/>
-            <a:ext cx="6355080" cy="3575304"/>
-          </a:xfrm>
-          <a:prstGeom prst="rect">
-            <a:avLst/>
-          </a:prstGeom>
-          <a:ln w="9525">
-            <a:solidFill>
-              <a:srgbClr val="0072CE"/>
-            </a:solidFill>
-          </a:ln>
-        </p:spPr>
-      </p:pic>
-      <p:sp>
-        <p:nvSpPr>
-          <p:cNvPr id="6" name="TextBox 5"/>
-          <p:cNvSpPr txBox="1"/>
-          <p:nvPr/>
-        </p:nvSpPr>
-        <p:spPr>
-          <a:xfrm>
-            <a:off x="548640" y="4736592"/>
-            <a:ext cx="8046720" cy="320040"/>
-          </a:xfrm>
-          <a:prstGeom prst="rect">
-            <a:avLst/>
-          </a:prstGeom>
-          <a:noFill/>
-        </p:spPr>
-        <p:txBody>
-          <a:bodyPr wrap="square" anchor="t">
-            <a:spAutoFit/>
-          </a:bodyPr>
-          <a:lstStyle/>
-          <a:p>
-            <a:pPr algn="ctr"/>
-            <a:r>
-              <a:rPr sz="1100" b="0" i="1">
-                <a:solidFill>
-                  <a:srgbClr val="8A8C8F"/>
-                </a:solidFill>
-                <a:latin typeface="Calibri"/>
-              </a:rPr>
-              <a:t>Matriz por cartera (MEF · BCE · Δ). Rojo = diferencia. Suma préstamo por préstamo, exacto al centavo.</a:t>
-            </a:r>
-          </a:p>
-        </p:txBody>
-      </p:sp>
-    </p:spTree>
-  </p:cSld>
-  <p:clrMapOvr>
-    <a:masterClrMapping/>
-  </p:clrMapOvr>
-</p:sld>
-</file>
-
-<file path=ppt/slides/slide7.xml><?xml version="1.0" encoding="utf-8"?>
-<p:sld xmlns:a="http://schemas.openxmlformats.org/drawingml/2006/main" xmlns:p="http://schemas.openxmlformats.org/presentationml/2006/main" xmlns:r="http://schemas.openxmlformats.org/officeDocument/2006/relationships">
-  <p:cSld>
-    <p:spTree>
-      <p:nvGrpSpPr>
-        <p:cNvPr id="1" name=""/>
-        <p:cNvGrpSpPr/>
-        <p:nvPr/>
-      </p:nvGrpSpPr>
-      <p:grpSpPr/>
-      <p:sp>
-        <p:nvSpPr>
-          <p:cNvPr id="2" name="Rectangle 1"/>
-          <p:cNvSpPr/>
-          <p:nvPr/>
-        </p:nvSpPr>
-        <p:spPr>
-          <a:xfrm>
-            <a:off x="566928" y="411480"/>
-            <a:ext cx="82296" cy="457200"/>
-          </a:xfrm>
-          <a:prstGeom prst="rect">
-            <a:avLst/>
-          </a:prstGeom>
-          <a:solidFill>
-            <a:srgbClr val="C8961B"/>
-          </a:solidFill>
-          <a:ln>
-            <a:noFill/>
-          </a:ln>
-        </p:spPr>
-        <p:style>
-          <a:lnRef idx="1">
-            <a:schemeClr val="accent1"/>
-          </a:lnRef>
-          <a:fillRef idx="3">
-            <a:schemeClr val="accent1"/>
-          </a:fillRef>
-          <a:effectRef idx="2">
-            <a:schemeClr val="accent1"/>
-          </a:effectRef>
-          <a:fontRef idx="minor">
-            <a:schemeClr val="lt1"/>
-          </a:fontRef>
-        </p:style>
-        <p:txBody>
-          <a:bodyPr rtlCol="0" anchor="ctr"/>
-          <a:lstStyle/>
-          <a:p>
-            <a:pPr algn="ctr"/>
-          </a:p>
-        </p:txBody>
-      </p:sp>
-      <p:sp>
-        <p:nvSpPr>
-          <p:cNvPr id="3" name="TextBox 2"/>
-          <p:cNvSpPr txBox="1"/>
-          <p:nvPr/>
-        </p:nvSpPr>
-        <p:spPr>
-          <a:xfrm>
-            <a:off x="768096" y="365760"/>
-            <a:ext cx="7479792" cy="640080"/>
-          </a:xfrm>
-          <a:prstGeom prst="rect">
-            <a:avLst/>
-          </a:prstGeom>
-          <a:noFill/>
-        </p:spPr>
-        <p:txBody>
-          <a:bodyPr wrap="square" anchor="t">
-            <a:spAutoFit/>
-          </a:bodyPr>
-          <a:lstStyle/>
-          <a:p>
-            <a:r>
-              <a:rPr sz="2600" b="1" i="0">
-                <a:solidFill>
-                  <a:srgbClr val="003A70"/>
-                </a:solidFill>
-                <a:latin typeface="Calibri"/>
-              </a:rPr>
-              <a:t>Paso III · Gestión de Observaciones</a:t>
-            </a:r>
-          </a:p>
-        </p:txBody>
-      </p:sp>
-      <p:sp>
-        <p:nvSpPr>
-          <p:cNvPr id="4" name="TextBox 3"/>
-          <p:cNvSpPr txBox="1"/>
-          <p:nvPr/>
-        </p:nvSpPr>
-        <p:spPr>
-          <a:xfrm>
-            <a:off x="768096" y="932688"/>
-            <a:ext cx="7479792" cy="365760"/>
-          </a:xfrm>
-          <a:prstGeom prst="rect">
-            <a:avLst/>
-          </a:prstGeom>
-          <a:noFill/>
-        </p:spPr>
-        <p:txBody>
-          <a:bodyPr wrap="square" anchor="t">
-            <a:spAutoFit/>
-          </a:bodyPr>
-          <a:lstStyle/>
-          <a:p>
-            <a:r>
-              <a:rPr sz="1300" b="0" i="1">
-                <a:solidFill>
-                  <a:srgbClr val="8A8C8F"/>
-                </a:solidFill>
-                <a:latin typeface="Calibri"/>
-              </a:rPr>
-              <a:t>Identifica el préstamo exacto que no cuadra</a:t>
-            </a:r>
-          </a:p>
-        </p:txBody>
-      </p:sp>
-      <p:pic>
-        <p:nvPicPr>
-          <p:cNvPr id="5" name="Picture 4" descr="s3_observaciones.png"/>
-          <p:cNvPicPr>
-            <a:picLocks noChangeAspect="1"/>
-          </p:cNvPicPr>
-          <p:nvPr/>
-        </p:nvPicPr>
-        <p:blipFill>
-          <a:blip r:embed="rId2"/>
-          <a:stretch>
-            <a:fillRect/>
-          </a:stretch>
-        </p:blipFill>
-        <p:spPr>
-          <a:xfrm>
-            <a:off x="1394460" y="1097280"/>
-            <a:ext cx="6355080" cy="3575304"/>
-          </a:xfrm>
-          <a:prstGeom prst="rect">
-            <a:avLst/>
-          </a:prstGeom>
-          <a:ln w="9525">
-            <a:solidFill>
-              <a:srgbClr val="0072CE"/>
-            </a:solidFill>
-          </a:ln>
-        </p:spPr>
-      </p:pic>
-      <p:sp>
-        <p:nvSpPr>
-          <p:cNvPr id="6" name="TextBox 5"/>
-          <p:cNvSpPr txBox="1"/>
-          <p:nvPr/>
-        </p:nvSpPr>
-        <p:spPr>
-          <a:xfrm>
-            <a:off x="548640" y="4736592"/>
-            <a:ext cx="8046720" cy="320040"/>
-          </a:xfrm>
-          <a:prstGeom prst="rect">
-            <a:avLst/>
-          </a:prstGeom>
-          <a:noFill/>
-        </p:spPr>
-        <p:txBody>
-          <a:bodyPr wrap="square" anchor="t">
-            <a:spAutoFit/>
-          </a:bodyPr>
-          <a:lstStyle/>
-          <a:p>
-            <a:pPr algn="ctr"/>
-            <a:r>
-              <a:rPr sz="1100" b="0" i="1">
-                <a:solidFill>
-                  <a:srgbClr val="8A8C8F"/>
-                </a:solidFill>
-                <a:latin typeface="Calibri"/>
-              </a:rPr>
-              <a:t>Señala el crédito (ej. BIRF-8888), lo clasifica (Pago Directo) y permite subir el respaldo y agregarlo al BCE.</a:t>
-            </a:r>
-          </a:p>
-        </p:txBody>
-      </p:sp>
-    </p:spTree>
-  </p:cSld>
-  <p:clrMapOvr>
-    <a:masterClrMapping/>
-  </p:clrMapOvr>
-</p:sld>
-</file>
-
-<file path=ppt/slides/slide8.xml><?xml version="1.0" encoding="utf-8"?>
-<p:sld xmlns:a="http://schemas.openxmlformats.org/drawingml/2006/main" xmlns:p="http://schemas.openxmlformats.org/presentationml/2006/main" xmlns:r="http://schemas.openxmlformats.org/officeDocument/2006/relationships">
-  <p:cSld>
-    <p:spTree>
-      <p:nvGrpSpPr>
-        <p:cNvPr id="1" name=""/>
-        <p:cNvGrpSpPr/>
-        <p:nvPr/>
-      </p:nvGrpSpPr>
-      <p:grpSpPr/>
-      <p:sp>
-        <p:nvSpPr>
-          <p:cNvPr id="2" name="Rectangle 1"/>
-          <p:cNvSpPr/>
-          <p:nvPr/>
-        </p:nvSpPr>
-        <p:spPr>
-          <a:xfrm>
-            <a:off x="566928" y="411480"/>
-            <a:ext cx="82296" cy="457200"/>
-          </a:xfrm>
-          <a:prstGeom prst="rect">
-            <a:avLst/>
-          </a:prstGeom>
-          <a:solidFill>
-            <a:srgbClr val="C8961B"/>
-          </a:solidFill>
-          <a:ln>
-            <a:noFill/>
-          </a:ln>
-        </p:spPr>
-        <p:style>
-          <a:lnRef idx="1">
-            <a:schemeClr val="accent1"/>
-          </a:lnRef>
-          <a:fillRef idx="3">
-            <a:schemeClr val="accent1"/>
-          </a:fillRef>
-          <a:effectRef idx="2">
-            <a:schemeClr val="accent1"/>
-          </a:effectRef>
-          <a:fontRef idx="minor">
-            <a:schemeClr val="lt1"/>
-          </a:fontRef>
-        </p:style>
-        <p:txBody>
-          <a:bodyPr rtlCol="0" anchor="ctr"/>
-          <a:lstStyle/>
-          <a:p>
-            <a:pPr algn="ctr"/>
-          </a:p>
-        </p:txBody>
-      </p:sp>
-      <p:sp>
-        <p:nvSpPr>
-          <p:cNvPr id="3" name="TextBox 2"/>
-          <p:cNvSpPr txBox="1"/>
-          <p:nvPr/>
-        </p:nvSpPr>
-        <p:spPr>
-          <a:xfrm>
-            <a:off x="768096" y="365760"/>
-            <a:ext cx="7479792" cy="640080"/>
-          </a:xfrm>
-          <a:prstGeom prst="rect">
-            <a:avLst/>
-          </a:prstGeom>
-          <a:noFill/>
-        </p:spPr>
-        <p:txBody>
-          <a:bodyPr wrap="square" anchor="t">
-            <a:spAutoFit/>
-          </a:bodyPr>
-          <a:lstStyle/>
-          <a:p>
-            <a:r>
-              <a:rPr sz="2600" b="1" i="0">
-                <a:solidFill>
-                  <a:srgbClr val="003A70"/>
-                </a:solidFill>
-                <a:latin typeface="Calibri"/>
-              </a:rPr>
               <a:t>Paso IV · Emisión del Oficio (Quipux)</a:t>
             </a:r>
           </a:p>
@@ -6011,7 +4242,7 @@
 </p:sld>
 </file>
 
-<file path=ppt/slides/slide9.xml><?xml version="1.0" encoding="utf-8"?>
+<file path=ppt/slides/slide11.xml><?xml version="1.0" encoding="utf-8"?>
 <p:sld xmlns:a="http://schemas.openxmlformats.org/drawingml/2006/main" xmlns:p="http://schemas.openxmlformats.org/presentationml/2006/main" xmlns:r="http://schemas.openxmlformats.org/officeDocument/2006/relationships">
   <p:cSld>
     <p:spTree>
@@ -6400,6 +4631,2199 @@
           </a:graphicData>
         </a:graphic>
       </p:graphicFrame>
+    </p:spTree>
+  </p:cSld>
+  <p:clrMapOvr>
+    <a:masterClrMapping/>
+  </p:clrMapOvr>
+</p:sld>
+</file>
+
+<file path=ppt/slides/slide12.xml><?xml version="1.0" encoding="utf-8"?>
+<p:sld xmlns:a="http://schemas.openxmlformats.org/drawingml/2006/main" xmlns:p="http://schemas.openxmlformats.org/presentationml/2006/main" xmlns:r="http://schemas.openxmlformats.org/officeDocument/2006/relationships">
+  <p:cSld>
+    <p:spTree>
+      <p:nvGrpSpPr>
+        <p:cNvPr id="1" name=""/>
+        <p:cNvGrpSpPr/>
+        <p:nvPr/>
+      </p:nvGrpSpPr>
+      <p:grpSpPr/>
+      <p:sp>
+        <p:nvSpPr>
+          <p:cNvPr id="2" name="Rectangle 1"/>
+          <p:cNvSpPr/>
+          <p:nvPr/>
+        </p:nvSpPr>
+        <p:spPr>
+          <a:xfrm>
+            <a:off x="566928" y="411480"/>
+            <a:ext cx="82296" cy="457200"/>
+          </a:xfrm>
+          <a:prstGeom prst="rect">
+            <a:avLst/>
+          </a:prstGeom>
+          <a:solidFill>
+            <a:srgbClr val="C8961B"/>
+          </a:solidFill>
+          <a:ln>
+            <a:noFill/>
+          </a:ln>
+        </p:spPr>
+        <p:style>
+          <a:lnRef idx="1">
+            <a:schemeClr val="accent1"/>
+          </a:lnRef>
+          <a:fillRef idx="3">
+            <a:schemeClr val="accent1"/>
+          </a:fillRef>
+          <a:effectRef idx="2">
+            <a:schemeClr val="accent1"/>
+          </a:effectRef>
+          <a:fontRef idx="minor">
+            <a:schemeClr val="lt1"/>
+          </a:fontRef>
+        </p:style>
+        <p:txBody>
+          <a:bodyPr rtlCol="0" anchor="ctr"/>
+          <a:lstStyle/>
+          <a:p>
+            <a:pPr algn="ctr"/>
+          </a:p>
+        </p:txBody>
+      </p:sp>
+      <p:sp>
+        <p:nvSpPr>
+          <p:cNvPr id="3" name="TextBox 2"/>
+          <p:cNvSpPr txBox="1"/>
+          <p:nvPr/>
+        </p:nvSpPr>
+        <p:spPr>
+          <a:xfrm>
+            <a:off x="768096" y="365760"/>
+            <a:ext cx="7479792" cy="640080"/>
+          </a:xfrm>
+          <a:prstGeom prst="rect">
+            <a:avLst/>
+          </a:prstGeom>
+          <a:noFill/>
+        </p:spPr>
+        <p:txBody>
+          <a:bodyPr wrap="square" anchor="t">
+            <a:spAutoFit/>
+          </a:bodyPr>
+          <a:lstStyle/>
+          <a:p>
+            <a:r>
+              <a:rPr sz="2600" b="1" i="0">
+                <a:solidFill>
+                  <a:srgbClr val="003A70"/>
+                </a:solidFill>
+                <a:latin typeface="Calibri"/>
+              </a:rPr>
+              <a:t>Seguridad y despliegue</a:t>
+            </a:r>
+          </a:p>
+        </p:txBody>
+      </p:sp>
+      <p:sp>
+        <p:nvSpPr>
+          <p:cNvPr id="4" name="TextBox 3"/>
+          <p:cNvSpPr txBox="1"/>
+          <p:nvPr/>
+        </p:nvSpPr>
+        <p:spPr>
+          <a:xfrm>
+            <a:off x="566928" y="1417320"/>
+            <a:ext cx="7845552" cy="3177540"/>
+          </a:xfrm>
+          <a:prstGeom prst="rect">
+            <a:avLst/>
+          </a:prstGeom>
+          <a:noFill/>
+        </p:spPr>
+        <p:txBody>
+          <a:bodyPr wrap="square" anchor="t">
+            <a:spAutoFit/>
+          </a:bodyPr>
+          <a:lstStyle/>
+          <a:p>
+            <a:pPr>
+              <a:spcAft>
+                <a:spcPts val="1000"/>
+              </a:spcAft>
+            </a:pPr>
+            <a:r>
+              <a:rPr sz="1500" b="0" i="0">
+                <a:solidFill>
+                  <a:srgbClr val="58595B"/>
+                </a:solidFill>
+                <a:latin typeface="Calibri"/>
+              </a:rPr>
+              <a:t>●  Corre localmente en la PC (http://127.0.0.1:5001): los datos no salen a internet.</a:t>
+            </a:r>
+          </a:p>
+          <a:p>
+            <a:pPr>
+              <a:spcAft>
+                <a:spcPts val="1000"/>
+              </a:spcAft>
+            </a:pPr>
+            <a:r>
+              <a:rPr sz="1500" b="0" i="0">
+                <a:solidFill>
+                  <a:srgbClr val="58595B"/>
+                </a:solidFill>
+                <a:latin typeface="Calibri"/>
+              </a:rPr>
+              <a:t>●  Base de datos local para el historial de conciliaciones.</a:t>
+            </a:r>
+          </a:p>
+          <a:p>
+            <a:pPr>
+              <a:spcAft>
+                <a:spcPts val="1000"/>
+              </a:spcAft>
+            </a:pPr>
+            <a:r>
+              <a:rPr sz="1500" b="0" i="0">
+                <a:solidFill>
+                  <a:srgbClr val="58595B"/>
+                </a:solidFill>
+                <a:latin typeface="Calibri"/>
+              </a:rPr>
+              <a:t>●  Se inicia con doble clic; no requiere instalación compleja.</a:t>
+            </a:r>
+          </a:p>
+          <a:p>
+            <a:pPr>
+              <a:spcAft>
+                <a:spcPts val="1000"/>
+              </a:spcAft>
+            </a:pPr>
+            <a:r>
+              <a:rPr sz="1500" b="0" i="0">
+                <a:solidFill>
+                  <a:srgbClr val="58595B"/>
+                </a:solidFill>
+                <a:latin typeface="Calibri"/>
+              </a:rPr>
+              <a:t>●  Identidad institucional del BCE y respaldo del código versionado.</a:t>
+            </a:r>
+          </a:p>
+        </p:txBody>
+      </p:sp>
+    </p:spTree>
+  </p:cSld>
+  <p:clrMapOvr>
+    <a:masterClrMapping/>
+  </p:clrMapOvr>
+</p:sld>
+</file>
+
+<file path=ppt/slides/slide13.xml><?xml version="1.0" encoding="utf-8"?>
+<p:sld xmlns:a="http://schemas.openxmlformats.org/drawingml/2006/main" xmlns:p="http://schemas.openxmlformats.org/presentationml/2006/main" xmlns:r="http://schemas.openxmlformats.org/officeDocument/2006/relationships">
+  <p:cSld>
+    <p:spTree>
+      <p:nvGrpSpPr>
+        <p:cNvPr id="1" name=""/>
+        <p:cNvGrpSpPr/>
+        <p:nvPr/>
+      </p:nvGrpSpPr>
+      <p:grpSpPr/>
+      <p:sp>
+        <p:nvSpPr>
+          <p:cNvPr id="2" name="TextBox 1"/>
+          <p:cNvSpPr txBox="1"/>
+          <p:nvPr/>
+        </p:nvSpPr>
+        <p:spPr>
+          <a:xfrm>
+            <a:off x="566928" y="1737360"/>
+            <a:ext cx="7479792" cy="1645920"/>
+          </a:xfrm>
+          <a:prstGeom prst="rect">
+            <a:avLst/>
+          </a:prstGeom>
+          <a:noFill/>
+        </p:spPr>
+        <p:txBody>
+          <a:bodyPr wrap="square" anchor="ctr">
+            <a:spAutoFit/>
+          </a:bodyPr>
+          <a:lstStyle/>
+          <a:p>
+            <a:r>
+              <a:rPr sz="2800" b="1" i="0">
+                <a:solidFill>
+                  <a:srgbClr val="003A70"/>
+                </a:solidFill>
+                <a:latin typeface="Calibri"/>
+              </a:rPr>
+              <a:t>Conciliación exacta, rápida y trazable</a:t>
+            </a:r>
+          </a:p>
+          <a:p>
+            <a:r>
+              <a:rPr sz="1600" b="0" i="0">
+                <a:solidFill>
+                  <a:srgbClr val="58595B"/>
+                </a:solidFill>
+                <a:latin typeface="Calibri"/>
+              </a:rPr>
+              <a:t>De 4 horas mensuales a minutos, sin errores y con el oficio listo.</a:t>
+            </a:r>
+          </a:p>
+          <a:p>
+            <a:pPr>
+              <a:spcBef>
+                <a:spcPts val="1800"/>
+              </a:spcBef>
+            </a:pPr>
+            <a:r>
+              <a:rPr sz="2000" b="1" i="0">
+                <a:solidFill>
+                  <a:srgbClr val="C8961B"/>
+                </a:solidFill>
+                <a:latin typeface="Calibri"/>
+              </a:rPr>
+              <a:t>Gracias.</a:t>
+            </a:r>
+          </a:p>
+        </p:txBody>
+      </p:sp>
+    </p:spTree>
+  </p:cSld>
+  <p:clrMapOvr>
+    <a:masterClrMapping/>
+  </p:clrMapOvr>
+</p:sld>
+</file>
+
+<file path=ppt/slides/slide2.xml><?xml version="1.0" encoding="utf-8"?>
+<p:sld xmlns:a="http://schemas.openxmlformats.org/drawingml/2006/main" xmlns:p="http://schemas.openxmlformats.org/presentationml/2006/main" xmlns:r="http://schemas.openxmlformats.org/officeDocument/2006/relationships">
+  <p:cSld>
+    <p:spTree>
+      <p:nvGrpSpPr>
+        <p:cNvPr id="1" name=""/>
+        <p:cNvGrpSpPr/>
+        <p:nvPr/>
+      </p:nvGrpSpPr>
+      <p:grpSpPr/>
+      <p:sp>
+        <p:nvSpPr>
+          <p:cNvPr id="2" name="Rectangle 1"/>
+          <p:cNvSpPr/>
+          <p:nvPr/>
+        </p:nvSpPr>
+        <p:spPr>
+          <a:xfrm>
+            <a:off x="566928" y="411480"/>
+            <a:ext cx="82296" cy="457200"/>
+          </a:xfrm>
+          <a:prstGeom prst="rect">
+            <a:avLst/>
+          </a:prstGeom>
+          <a:solidFill>
+            <a:srgbClr val="C8961B"/>
+          </a:solidFill>
+          <a:ln>
+            <a:noFill/>
+          </a:ln>
+        </p:spPr>
+        <p:style>
+          <a:lnRef idx="1">
+            <a:schemeClr val="accent1"/>
+          </a:lnRef>
+          <a:fillRef idx="3">
+            <a:schemeClr val="accent1"/>
+          </a:fillRef>
+          <a:effectRef idx="2">
+            <a:schemeClr val="accent1"/>
+          </a:effectRef>
+          <a:fontRef idx="minor">
+            <a:schemeClr val="lt1"/>
+          </a:fontRef>
+        </p:style>
+        <p:txBody>
+          <a:bodyPr rtlCol="0" anchor="ctr"/>
+          <a:lstStyle/>
+          <a:p>
+            <a:pPr algn="ctr"/>
+          </a:p>
+        </p:txBody>
+      </p:sp>
+      <p:sp>
+        <p:nvSpPr>
+          <p:cNvPr id="3" name="TextBox 2"/>
+          <p:cNvSpPr txBox="1"/>
+          <p:nvPr/>
+        </p:nvSpPr>
+        <p:spPr>
+          <a:xfrm>
+            <a:off x="768096" y="365760"/>
+            <a:ext cx="7479792" cy="640080"/>
+          </a:xfrm>
+          <a:prstGeom prst="rect">
+            <a:avLst/>
+          </a:prstGeom>
+          <a:noFill/>
+        </p:spPr>
+        <p:txBody>
+          <a:bodyPr wrap="square" anchor="t">
+            <a:spAutoFit/>
+          </a:bodyPr>
+          <a:lstStyle/>
+          <a:p>
+            <a:r>
+              <a:rPr sz="2600" b="1" i="0">
+                <a:solidFill>
+                  <a:srgbClr val="003A70"/>
+                </a:solidFill>
+                <a:latin typeface="Calibri"/>
+              </a:rPr>
+              <a:t>El problema: la conciliación manual</a:t>
+            </a:r>
+          </a:p>
+        </p:txBody>
+      </p:sp>
+      <p:sp>
+        <p:nvSpPr>
+          <p:cNvPr id="4" name="TextBox 3"/>
+          <p:cNvSpPr txBox="1"/>
+          <p:nvPr/>
+        </p:nvSpPr>
+        <p:spPr>
+          <a:xfrm>
+            <a:off x="768096" y="932688"/>
+            <a:ext cx="7479792" cy="365760"/>
+          </a:xfrm>
+          <a:prstGeom prst="rect">
+            <a:avLst/>
+          </a:prstGeom>
+          <a:noFill/>
+        </p:spPr>
+        <p:txBody>
+          <a:bodyPr wrap="square" anchor="t">
+            <a:spAutoFit/>
+          </a:bodyPr>
+          <a:lstStyle/>
+          <a:p>
+            <a:r>
+              <a:rPr sz="1300" b="0" i="1">
+                <a:solidFill>
+                  <a:srgbClr val="8A8C8F"/>
+                </a:solidFill>
+                <a:latin typeface="Calibri"/>
+              </a:rPr>
+              <a:t>Situación antes de la automatización</a:t>
+            </a:r>
+          </a:p>
+        </p:txBody>
+      </p:sp>
+      <p:sp>
+        <p:nvSpPr>
+          <p:cNvPr id="5" name="TextBox 4"/>
+          <p:cNvSpPr txBox="1"/>
+          <p:nvPr/>
+        </p:nvSpPr>
+        <p:spPr>
+          <a:xfrm>
+            <a:off x="566928" y="1417320"/>
+            <a:ext cx="7845552" cy="3177540"/>
+          </a:xfrm>
+          <a:prstGeom prst="rect">
+            <a:avLst/>
+          </a:prstGeom>
+          <a:noFill/>
+        </p:spPr>
+        <p:txBody>
+          <a:bodyPr wrap="square" anchor="t">
+            <a:spAutoFit/>
+          </a:bodyPr>
+          <a:lstStyle/>
+          <a:p>
+            <a:pPr>
+              <a:spcAft>
+                <a:spcPts val="1000"/>
+              </a:spcAft>
+            </a:pPr>
+            <a:r>
+              <a:rPr sz="1500" b="0" i="0">
+                <a:solidFill>
+                  <a:srgbClr val="58595B"/>
+                </a:solidFill>
+                <a:latin typeface="Calibri"/>
+              </a:rPr>
+              <a:t>●  Cada mes se cruzan los pagos de deuda externa entre el MEF y el BCE (Agente Oficial).</a:t>
+            </a:r>
+          </a:p>
+          <a:p>
+            <a:pPr>
+              <a:spcAft>
+                <a:spcPts val="1000"/>
+              </a:spcAft>
+            </a:pPr>
+            <a:r>
+              <a:rPr sz="1500" b="0" i="0">
+                <a:solidFill>
+                  <a:srgbClr val="58595B"/>
+                </a:solidFill>
+                <a:latin typeface="Calibri"/>
+              </a:rPr>
+              <a:t>●  Se comparan 6 rubros por cada acreedor: desembolsos, amortizaciones, intereses, comisiones, condonados e interés por mora.</a:t>
+            </a:r>
+          </a:p>
+          <a:p>
+            <a:pPr>
+              <a:spcAft>
+                <a:spcPts val="1000"/>
+              </a:spcAft>
+            </a:pPr>
+            <a:r>
+              <a:rPr sz="1500" b="0" i="0">
+                <a:solidFill>
+                  <a:srgbClr val="58595B"/>
+                </a:solidFill>
+                <a:latin typeface="Calibri"/>
+              </a:rPr>
+              <a:t>●  Revisión préstamo por préstamo en archivos Excel extensos, sumando y cuadrando valor por valor, uno a uno.</a:t>
+            </a:r>
+          </a:p>
+          <a:p>
+            <a:pPr>
+              <a:spcAft>
+                <a:spcPts val="1000"/>
+              </a:spcAft>
+            </a:pPr>
+            <a:r>
+              <a:rPr sz="1500" b="1" i="0">
+                <a:solidFill>
+                  <a:srgbClr val="C0392B"/>
+                </a:solidFill>
+                <a:latin typeface="Calibri"/>
+              </a:rPr>
+              <a:t>●  Toma en promedio 4 horas mensuales, con alto riesgo de error humano.</a:t>
+            </a:r>
+          </a:p>
+          <a:p>
+            <a:pPr>
+              <a:spcAft>
+                <a:spcPts val="1000"/>
+              </a:spcAft>
+            </a:pPr>
+            <a:r>
+              <a:rPr sz="1500" b="0" i="0">
+                <a:solidFill>
+                  <a:srgbClr val="58595B"/>
+                </a:solidFill>
+                <a:latin typeface="Calibri"/>
+              </a:rPr>
+              <a:t>●  Además, había que redactar manualmente el oficio de respuesta (Quipux).</a:t>
+            </a:r>
+          </a:p>
+        </p:txBody>
+      </p:sp>
+    </p:spTree>
+  </p:cSld>
+  <p:clrMapOvr>
+    <a:masterClrMapping/>
+  </p:clrMapOvr>
+</p:sld>
+</file>
+
+<file path=ppt/slides/slide3.xml><?xml version="1.0" encoding="utf-8"?>
+<p:sld xmlns:a="http://schemas.openxmlformats.org/drawingml/2006/main" xmlns:p="http://schemas.openxmlformats.org/presentationml/2006/main" xmlns:r="http://schemas.openxmlformats.org/officeDocument/2006/relationships">
+  <p:cSld>
+    <p:spTree>
+      <p:nvGrpSpPr>
+        <p:cNvPr id="1" name=""/>
+        <p:cNvGrpSpPr/>
+        <p:nvPr/>
+      </p:nvGrpSpPr>
+      <p:grpSpPr/>
+      <p:sp>
+        <p:nvSpPr>
+          <p:cNvPr id="2" name="Rectangle 1"/>
+          <p:cNvSpPr/>
+          <p:nvPr/>
+        </p:nvSpPr>
+        <p:spPr>
+          <a:xfrm>
+            <a:off x="566928" y="411480"/>
+            <a:ext cx="82296" cy="457200"/>
+          </a:xfrm>
+          <a:prstGeom prst="rect">
+            <a:avLst/>
+          </a:prstGeom>
+          <a:solidFill>
+            <a:srgbClr val="C8961B"/>
+          </a:solidFill>
+          <a:ln>
+            <a:noFill/>
+          </a:ln>
+        </p:spPr>
+        <p:style>
+          <a:lnRef idx="1">
+            <a:schemeClr val="accent1"/>
+          </a:lnRef>
+          <a:fillRef idx="3">
+            <a:schemeClr val="accent1"/>
+          </a:fillRef>
+          <a:effectRef idx="2">
+            <a:schemeClr val="accent1"/>
+          </a:effectRef>
+          <a:fontRef idx="minor">
+            <a:schemeClr val="lt1"/>
+          </a:fontRef>
+        </p:style>
+        <p:txBody>
+          <a:bodyPr rtlCol="0" anchor="ctr"/>
+          <a:lstStyle/>
+          <a:p>
+            <a:pPr algn="ctr"/>
+          </a:p>
+        </p:txBody>
+      </p:sp>
+      <p:sp>
+        <p:nvSpPr>
+          <p:cNvPr id="3" name="TextBox 2"/>
+          <p:cNvSpPr txBox="1"/>
+          <p:nvPr/>
+        </p:nvSpPr>
+        <p:spPr>
+          <a:xfrm>
+            <a:off x="768096" y="365760"/>
+            <a:ext cx="7479792" cy="640080"/>
+          </a:xfrm>
+          <a:prstGeom prst="rect">
+            <a:avLst/>
+          </a:prstGeom>
+          <a:noFill/>
+        </p:spPr>
+        <p:txBody>
+          <a:bodyPr wrap="square" anchor="t">
+            <a:spAutoFit/>
+          </a:bodyPr>
+          <a:lstStyle/>
+          <a:p>
+            <a:r>
+              <a:rPr sz="2600" b="1" i="0">
+                <a:solidFill>
+                  <a:srgbClr val="003A70"/>
+                </a:solidFill>
+                <a:latin typeface="Calibri"/>
+              </a:rPr>
+              <a:t>ANTES · Conciliación manual</a:t>
+            </a:r>
+          </a:p>
+        </p:txBody>
+      </p:sp>
+      <p:sp>
+        <p:nvSpPr>
+          <p:cNvPr id="4" name="TextBox 3"/>
+          <p:cNvSpPr txBox="1"/>
+          <p:nvPr/>
+        </p:nvSpPr>
+        <p:spPr>
+          <a:xfrm>
+            <a:off x="768096" y="932688"/>
+            <a:ext cx="7479792" cy="365760"/>
+          </a:xfrm>
+          <a:prstGeom prst="rect">
+            <a:avLst/>
+          </a:prstGeom>
+          <a:noFill/>
+        </p:spPr>
+        <p:txBody>
+          <a:bodyPr wrap="square" anchor="t">
+            <a:spAutoFit/>
+          </a:bodyPr>
+          <a:lstStyle/>
+          <a:p>
+            <a:r>
+              <a:rPr sz="1300" b="0" i="1">
+                <a:solidFill>
+                  <a:srgbClr val="8A8C8F"/>
+                </a:solidFill>
+                <a:latin typeface="Calibri"/>
+              </a:rPr>
+              <a:t>Así se hacía cada mes</a:t>
+            </a:r>
+          </a:p>
+        </p:txBody>
+      </p:sp>
+      <p:pic>
+        <p:nvPicPr>
+          <p:cNvPr id="5" name="Picture 4" descr="antes_excel_crop.png"/>
+          <p:cNvPicPr>
+            <a:picLocks noChangeAspect="1"/>
+          </p:cNvPicPr>
+          <p:nvPr/>
+        </p:nvPicPr>
+        <p:blipFill>
+          <a:blip r:embed="rId2"/>
+          <a:stretch>
+            <a:fillRect/>
+          </a:stretch>
+        </p:blipFill>
+        <p:spPr>
+          <a:xfrm>
+            <a:off x="502920" y="1234440"/>
+            <a:ext cx="8138160" cy="2616731"/>
+          </a:xfrm>
+          <a:prstGeom prst="rect">
+            <a:avLst/>
+          </a:prstGeom>
+          <a:ln w="15875">
+            <a:solidFill>
+              <a:srgbClr val="C0392B"/>
+            </a:solidFill>
+          </a:ln>
+        </p:spPr>
+      </p:pic>
+      <p:sp>
+        <p:nvSpPr>
+          <p:cNvPr id="6" name="Rounded Rectangle 5"/>
+          <p:cNvSpPr/>
+          <p:nvPr/>
+        </p:nvSpPr>
+        <p:spPr>
+          <a:xfrm>
+            <a:off x="502920" y="3960899"/>
+            <a:ext cx="8138160" cy="502920"/>
+          </a:xfrm>
+          <a:prstGeom prst="roundRect">
+            <a:avLst/>
+          </a:prstGeom>
+          <a:solidFill>
+            <a:srgbClr val="C0392B"/>
+          </a:solidFill>
+          <a:ln>
+            <a:noFill/>
+          </a:ln>
+          <a:effectLst/>
+        </p:spPr>
+        <p:style>
+          <a:lnRef idx="1">
+            <a:schemeClr val="accent1"/>
+          </a:lnRef>
+          <a:fillRef idx="3">
+            <a:schemeClr val="accent1"/>
+          </a:fillRef>
+          <a:effectRef idx="2">
+            <a:schemeClr val="accent1"/>
+          </a:effectRef>
+          <a:fontRef idx="minor">
+            <a:schemeClr val="lt1"/>
+          </a:fontRef>
+        </p:style>
+        <p:txBody>
+          <a:bodyPr rtlCol="0" anchor="ctr" wrap="square"/>
+          <a:lstStyle/>
+          <a:p>
+            <a:pPr algn="ctr"/>
+            <a:r>
+              <a:rPr sz="1400" b="1" i="0">
+                <a:solidFill>
+                  <a:srgbClr val="FFFFFF"/>
+                </a:solidFill>
+                <a:latin typeface="Calibri"/>
+              </a:rPr>
+              <a:t>Revisar y sumar préstamo por préstamo en Excel · ≈ 4 horas · alto riesgo de error</a:t>
+            </a:r>
+          </a:p>
+        </p:txBody>
+      </p:sp>
+    </p:spTree>
+  </p:cSld>
+  <p:clrMapOvr>
+    <a:masterClrMapping/>
+  </p:clrMapOvr>
+</p:sld>
+</file>
+
+<file path=ppt/slides/slide4.xml><?xml version="1.0" encoding="utf-8"?>
+<p:sld xmlns:a="http://schemas.openxmlformats.org/drawingml/2006/main" xmlns:p="http://schemas.openxmlformats.org/presentationml/2006/main" xmlns:r="http://schemas.openxmlformats.org/officeDocument/2006/relationships">
+  <p:cSld>
+    <p:spTree>
+      <p:nvGrpSpPr>
+        <p:cNvPr id="1" name=""/>
+        <p:cNvGrpSpPr/>
+        <p:nvPr/>
+      </p:nvGrpSpPr>
+      <p:grpSpPr/>
+      <p:sp>
+        <p:nvSpPr>
+          <p:cNvPr id="2" name="Rectangle 1"/>
+          <p:cNvSpPr/>
+          <p:nvPr/>
+        </p:nvSpPr>
+        <p:spPr>
+          <a:xfrm>
+            <a:off x="566928" y="411480"/>
+            <a:ext cx="82296" cy="457200"/>
+          </a:xfrm>
+          <a:prstGeom prst="rect">
+            <a:avLst/>
+          </a:prstGeom>
+          <a:solidFill>
+            <a:srgbClr val="C8961B"/>
+          </a:solidFill>
+          <a:ln>
+            <a:noFill/>
+          </a:ln>
+        </p:spPr>
+        <p:style>
+          <a:lnRef idx="1">
+            <a:schemeClr val="accent1"/>
+          </a:lnRef>
+          <a:fillRef idx="3">
+            <a:schemeClr val="accent1"/>
+          </a:fillRef>
+          <a:effectRef idx="2">
+            <a:schemeClr val="accent1"/>
+          </a:effectRef>
+          <a:fontRef idx="minor">
+            <a:schemeClr val="lt1"/>
+          </a:fontRef>
+        </p:style>
+        <p:txBody>
+          <a:bodyPr rtlCol="0" anchor="ctr"/>
+          <a:lstStyle/>
+          <a:p>
+            <a:pPr algn="ctr"/>
+          </a:p>
+        </p:txBody>
+      </p:sp>
+      <p:sp>
+        <p:nvSpPr>
+          <p:cNvPr id="3" name="TextBox 2"/>
+          <p:cNvSpPr txBox="1"/>
+          <p:nvPr/>
+        </p:nvSpPr>
+        <p:spPr>
+          <a:xfrm>
+            <a:off x="768096" y="365760"/>
+            <a:ext cx="7479792" cy="640080"/>
+          </a:xfrm>
+          <a:prstGeom prst="rect">
+            <a:avLst/>
+          </a:prstGeom>
+          <a:noFill/>
+        </p:spPr>
+        <p:txBody>
+          <a:bodyPr wrap="square" anchor="t">
+            <a:spAutoFit/>
+          </a:bodyPr>
+          <a:lstStyle/>
+          <a:p>
+            <a:r>
+              <a:rPr sz="2600" b="1" i="0">
+                <a:solidFill>
+                  <a:srgbClr val="003A70"/>
+                </a:solidFill>
+                <a:latin typeface="Calibri"/>
+              </a:rPr>
+              <a:t>DESPUÉS · Conciliación automatizada</a:t>
+            </a:r>
+          </a:p>
+        </p:txBody>
+      </p:sp>
+      <p:sp>
+        <p:nvSpPr>
+          <p:cNvPr id="4" name="TextBox 3"/>
+          <p:cNvSpPr txBox="1"/>
+          <p:nvPr/>
+        </p:nvSpPr>
+        <p:spPr>
+          <a:xfrm>
+            <a:off x="768096" y="932688"/>
+            <a:ext cx="7479792" cy="365760"/>
+          </a:xfrm>
+          <a:prstGeom prst="rect">
+            <a:avLst/>
+          </a:prstGeom>
+          <a:noFill/>
+        </p:spPr>
+        <p:txBody>
+          <a:bodyPr wrap="square" anchor="t">
+            <a:spAutoFit/>
+          </a:bodyPr>
+          <a:lstStyle/>
+          <a:p>
+            <a:r>
+              <a:rPr sz="1300" b="0" i="1">
+                <a:solidFill>
+                  <a:srgbClr val="8A8C8F"/>
+                </a:solidFill>
+                <a:latin typeface="Calibri"/>
+              </a:rPr>
+              <a:t>Con el sistema</a:t>
+            </a:r>
+          </a:p>
+        </p:txBody>
+      </p:sp>
+      <p:pic>
+        <p:nvPicPr>
+          <p:cNvPr id="5" name="Picture 4" descr="s2b_conciliado.png"/>
+          <p:cNvPicPr>
+            <a:picLocks noChangeAspect="1"/>
+          </p:cNvPicPr>
+          <p:nvPr/>
+        </p:nvPicPr>
+        <p:blipFill>
+          <a:blip r:embed="rId2"/>
+          <a:stretch>
+            <a:fillRect/>
+          </a:stretch>
+        </p:blipFill>
+        <p:spPr>
+          <a:xfrm>
+            <a:off x="1686560" y="1234440"/>
+            <a:ext cx="5770879" cy="3246120"/>
+          </a:xfrm>
+          <a:prstGeom prst="rect">
+            <a:avLst/>
+          </a:prstGeom>
+          <a:ln w="15875">
+            <a:solidFill>
+              <a:srgbClr val="1E824C"/>
+            </a:solidFill>
+          </a:ln>
+        </p:spPr>
+      </p:pic>
+      <p:sp>
+        <p:nvSpPr>
+          <p:cNvPr id="6" name="Rounded Rectangle 5"/>
+          <p:cNvSpPr/>
+          <p:nvPr/>
+        </p:nvSpPr>
+        <p:spPr>
+          <a:xfrm>
+            <a:off x="1686560" y="4590288"/>
+            <a:ext cx="5770879" cy="502920"/>
+          </a:xfrm>
+          <a:prstGeom prst="roundRect">
+            <a:avLst/>
+          </a:prstGeom>
+          <a:solidFill>
+            <a:srgbClr val="1E824C"/>
+          </a:solidFill>
+          <a:ln>
+            <a:noFill/>
+          </a:ln>
+          <a:effectLst/>
+        </p:spPr>
+        <p:style>
+          <a:lnRef idx="1">
+            <a:schemeClr val="accent1"/>
+          </a:lnRef>
+          <a:fillRef idx="3">
+            <a:schemeClr val="accent1"/>
+          </a:fillRef>
+          <a:effectRef idx="2">
+            <a:schemeClr val="accent1"/>
+          </a:effectRef>
+          <a:fontRef idx="minor">
+            <a:schemeClr val="lt1"/>
+          </a:fontRef>
+        </p:style>
+        <p:txBody>
+          <a:bodyPr rtlCol="0" anchor="ctr" wrap="square"/>
+          <a:lstStyle/>
+          <a:p>
+            <a:pPr algn="ctr"/>
+            <a:r>
+              <a:rPr sz="1400" b="1" i="0">
+                <a:solidFill>
+                  <a:srgbClr val="FFFFFF"/>
+                </a:solidFill>
+                <a:latin typeface="Calibri"/>
+              </a:rPr>
+              <a:t>Cruce y verificación automáticos · minutos · exacto al centavo · señala lo que no cuadra</a:t>
+            </a:r>
+          </a:p>
+        </p:txBody>
+      </p:sp>
+    </p:spTree>
+  </p:cSld>
+  <p:clrMapOvr>
+    <a:masterClrMapping/>
+  </p:clrMapOvr>
+</p:sld>
+</file>
+
+<file path=ppt/slides/slide5.xml><?xml version="1.0" encoding="utf-8"?>
+<p:sld xmlns:a="http://schemas.openxmlformats.org/drawingml/2006/main" xmlns:p="http://schemas.openxmlformats.org/presentationml/2006/main" xmlns:r="http://schemas.openxmlformats.org/officeDocument/2006/relationships">
+  <p:cSld>
+    <p:spTree>
+      <p:nvGrpSpPr>
+        <p:cNvPr id="1" name=""/>
+        <p:cNvGrpSpPr/>
+        <p:nvPr/>
+      </p:nvGrpSpPr>
+      <p:grpSpPr/>
+      <p:sp>
+        <p:nvSpPr>
+          <p:cNvPr id="2" name="Rectangle 1"/>
+          <p:cNvSpPr/>
+          <p:nvPr/>
+        </p:nvSpPr>
+        <p:spPr>
+          <a:xfrm>
+            <a:off x="566928" y="411480"/>
+            <a:ext cx="82296" cy="457200"/>
+          </a:xfrm>
+          <a:prstGeom prst="rect">
+            <a:avLst/>
+          </a:prstGeom>
+          <a:solidFill>
+            <a:srgbClr val="C8961B"/>
+          </a:solidFill>
+          <a:ln>
+            <a:noFill/>
+          </a:ln>
+        </p:spPr>
+        <p:style>
+          <a:lnRef idx="1">
+            <a:schemeClr val="accent1"/>
+          </a:lnRef>
+          <a:fillRef idx="3">
+            <a:schemeClr val="accent1"/>
+          </a:fillRef>
+          <a:effectRef idx="2">
+            <a:schemeClr val="accent1"/>
+          </a:effectRef>
+          <a:fontRef idx="minor">
+            <a:schemeClr val="lt1"/>
+          </a:fontRef>
+        </p:style>
+        <p:txBody>
+          <a:bodyPr rtlCol="0" anchor="ctr"/>
+          <a:lstStyle/>
+          <a:p>
+            <a:pPr algn="ctr"/>
+          </a:p>
+        </p:txBody>
+      </p:sp>
+      <p:sp>
+        <p:nvSpPr>
+          <p:cNvPr id="3" name="TextBox 2"/>
+          <p:cNvSpPr txBox="1"/>
+          <p:nvPr/>
+        </p:nvSpPr>
+        <p:spPr>
+          <a:xfrm>
+            <a:off x="768096" y="365760"/>
+            <a:ext cx="7479792" cy="640080"/>
+          </a:xfrm>
+          <a:prstGeom prst="rect">
+            <a:avLst/>
+          </a:prstGeom>
+          <a:noFill/>
+        </p:spPr>
+        <p:txBody>
+          <a:bodyPr wrap="square" anchor="t">
+            <a:spAutoFit/>
+          </a:bodyPr>
+          <a:lstStyle/>
+          <a:p>
+            <a:r>
+              <a:rPr sz="2600" b="1" i="0">
+                <a:solidFill>
+                  <a:srgbClr val="003A70"/>
+                </a:solidFill>
+                <a:latin typeface="Calibri"/>
+              </a:rPr>
+              <a:t>El impacto conseguido</a:t>
+            </a:r>
+          </a:p>
+        </p:txBody>
+      </p:sp>
+      <p:sp>
+        <p:nvSpPr>
+          <p:cNvPr id="4" name="Rounded Rectangle 3"/>
+          <p:cNvSpPr/>
+          <p:nvPr/>
+        </p:nvSpPr>
+        <p:spPr>
+          <a:xfrm>
+            <a:off x="566928" y="1554480"/>
+            <a:ext cx="3566160" cy="2286000"/>
+          </a:xfrm>
+          <a:prstGeom prst="roundRect">
+            <a:avLst/>
+          </a:prstGeom>
+          <a:solidFill>
+            <a:srgbClr val="FFFFFF"/>
+          </a:solidFill>
+          <a:ln w="19050">
+            <a:solidFill>
+              <a:srgbClr val="C0392B"/>
+            </a:solidFill>
+          </a:ln>
+          <a:effectLst/>
+        </p:spPr>
+        <p:style>
+          <a:lnRef idx="1">
+            <a:schemeClr val="accent1"/>
+          </a:lnRef>
+          <a:fillRef idx="3">
+            <a:schemeClr val="accent1"/>
+          </a:fillRef>
+          <a:effectRef idx="2">
+            <a:schemeClr val="accent1"/>
+          </a:effectRef>
+          <a:fontRef idx="minor">
+            <a:schemeClr val="lt1"/>
+          </a:fontRef>
+        </p:style>
+        <p:txBody>
+          <a:bodyPr rtlCol="0" anchor="ctr" wrap="square"/>
+          <a:lstStyle/>
+          <a:p>
+            <a:pPr algn="ctr"/>
+            <a:r>
+              <a:rPr sz="1500" b="1" i="0">
+                <a:solidFill>
+                  <a:srgbClr val="58595B"/>
+                </a:solidFill>
+                <a:latin typeface="Calibri"/>
+              </a:rPr>
+              <a:t>ANTES (manual)</a:t>
+            </a:r>
+          </a:p>
+          <a:p>
+            <a:pPr algn="ctr"/>
+            <a:r>
+              <a:rPr sz="4400" b="1" i="0">
+                <a:solidFill>
+                  <a:srgbClr val="C0392B"/>
+                </a:solidFill>
+                <a:latin typeface="Calibri"/>
+              </a:rPr>
+              <a:t>≈ 4 horas</a:t>
+            </a:r>
+          </a:p>
+          <a:p>
+            <a:pPr algn="ctr"/>
+            <a:r>
+              <a:rPr sz="1300" b="0" i="0">
+                <a:solidFill>
+                  <a:srgbClr val="8A8C8F"/>
+                </a:solidFill>
+                <a:latin typeface="Calibri"/>
+              </a:rPr>
+              <a:t>cada mes, revisando valor por valor</a:t>
+            </a:r>
+          </a:p>
+        </p:txBody>
+      </p:sp>
+      <p:sp>
+        <p:nvSpPr>
+          <p:cNvPr id="5" name="Rounded Rectangle 4"/>
+          <p:cNvSpPr/>
+          <p:nvPr/>
+        </p:nvSpPr>
+        <p:spPr>
+          <a:xfrm>
+            <a:off x="4498848" y="1554480"/>
+            <a:ext cx="3566160" cy="2286000"/>
+          </a:xfrm>
+          <a:prstGeom prst="roundRect">
+            <a:avLst/>
+          </a:prstGeom>
+          <a:solidFill>
+            <a:srgbClr val="FFFFFF"/>
+          </a:solidFill>
+          <a:ln w="19050">
+            <a:solidFill>
+              <a:srgbClr val="1E824C"/>
+            </a:solidFill>
+          </a:ln>
+          <a:effectLst/>
+        </p:spPr>
+        <p:style>
+          <a:lnRef idx="1">
+            <a:schemeClr val="accent1"/>
+          </a:lnRef>
+          <a:fillRef idx="3">
+            <a:schemeClr val="accent1"/>
+          </a:fillRef>
+          <a:effectRef idx="2">
+            <a:schemeClr val="accent1"/>
+          </a:effectRef>
+          <a:fontRef idx="minor">
+            <a:schemeClr val="lt1"/>
+          </a:fontRef>
+        </p:style>
+        <p:txBody>
+          <a:bodyPr rtlCol="0" anchor="ctr" wrap="square"/>
+          <a:lstStyle/>
+          <a:p>
+            <a:pPr algn="ctr"/>
+            <a:r>
+              <a:rPr sz="1500" b="1" i="0">
+                <a:solidFill>
+                  <a:srgbClr val="58595B"/>
+                </a:solidFill>
+                <a:latin typeface="Calibri"/>
+              </a:rPr>
+              <a:t>AHORA (automatizado)</a:t>
+            </a:r>
+          </a:p>
+          <a:p>
+            <a:pPr algn="ctr"/>
+            <a:r>
+              <a:rPr sz="4400" b="1" i="0">
+                <a:solidFill>
+                  <a:srgbClr val="1E824C"/>
+                </a:solidFill>
+                <a:latin typeface="Calibri"/>
+              </a:rPr>
+              <a:t>Minutos</a:t>
+            </a:r>
+          </a:p>
+          <a:p>
+            <a:pPr algn="ctr"/>
+            <a:r>
+              <a:rPr sz="1300" b="0" i="0">
+                <a:solidFill>
+                  <a:srgbClr val="8A8C8F"/>
+                </a:solidFill>
+                <a:latin typeface="Calibri"/>
+              </a:rPr>
+              <a:t>cruce y verificación automáticos</a:t>
+            </a:r>
+          </a:p>
+        </p:txBody>
+      </p:sp>
+      <p:sp>
+        <p:nvSpPr>
+          <p:cNvPr id="6" name="TextBox 5"/>
+          <p:cNvSpPr txBox="1"/>
+          <p:nvPr/>
+        </p:nvSpPr>
+        <p:spPr>
+          <a:xfrm>
+            <a:off x="566928" y="4069080"/>
+            <a:ext cx="7845552" cy="640080"/>
+          </a:xfrm>
+          <a:prstGeom prst="rect">
+            <a:avLst/>
+          </a:prstGeom>
+          <a:noFill/>
+        </p:spPr>
+        <p:txBody>
+          <a:bodyPr wrap="square" anchor="t">
+            <a:spAutoFit/>
+          </a:bodyPr>
+          <a:lstStyle/>
+          <a:p>
+            <a:pPr algn="ctr"/>
+            <a:r>
+              <a:rPr sz="1300" b="1" i="0">
+                <a:solidFill>
+                  <a:srgbClr val="003A70"/>
+                </a:solidFill>
+                <a:latin typeface="Calibri"/>
+              </a:rPr>
+              <a:t>Cálculo exacto al centavo · identifica el préstamo que no cuadra · genera el oficio de respuesta</a:t>
+            </a:r>
+          </a:p>
+        </p:txBody>
+      </p:sp>
+    </p:spTree>
+  </p:cSld>
+  <p:clrMapOvr>
+    <a:masterClrMapping/>
+  </p:clrMapOvr>
+</p:sld>
+</file>
+
+<file path=ppt/slides/slide6.xml><?xml version="1.0" encoding="utf-8"?>
+<p:sld xmlns:a="http://schemas.openxmlformats.org/drawingml/2006/main" xmlns:p="http://schemas.openxmlformats.org/presentationml/2006/main" xmlns:r="http://schemas.openxmlformats.org/officeDocument/2006/relationships">
+  <p:cSld>
+    <p:spTree>
+      <p:nvGrpSpPr>
+        <p:cNvPr id="1" name=""/>
+        <p:cNvGrpSpPr/>
+        <p:nvPr/>
+      </p:nvGrpSpPr>
+      <p:grpSpPr/>
+      <p:sp>
+        <p:nvSpPr>
+          <p:cNvPr id="2" name="Rectangle 1"/>
+          <p:cNvSpPr/>
+          <p:nvPr/>
+        </p:nvSpPr>
+        <p:spPr>
+          <a:xfrm>
+            <a:off x="566928" y="411480"/>
+            <a:ext cx="82296" cy="457200"/>
+          </a:xfrm>
+          <a:prstGeom prst="rect">
+            <a:avLst/>
+          </a:prstGeom>
+          <a:solidFill>
+            <a:srgbClr val="C8961B"/>
+          </a:solidFill>
+          <a:ln>
+            <a:noFill/>
+          </a:ln>
+        </p:spPr>
+        <p:style>
+          <a:lnRef idx="1">
+            <a:schemeClr val="accent1"/>
+          </a:lnRef>
+          <a:fillRef idx="3">
+            <a:schemeClr val="accent1"/>
+          </a:fillRef>
+          <a:effectRef idx="2">
+            <a:schemeClr val="accent1"/>
+          </a:effectRef>
+          <a:fontRef idx="minor">
+            <a:schemeClr val="lt1"/>
+          </a:fontRef>
+        </p:style>
+        <p:txBody>
+          <a:bodyPr rtlCol="0" anchor="ctr"/>
+          <a:lstStyle/>
+          <a:p>
+            <a:pPr algn="ctr"/>
+          </a:p>
+        </p:txBody>
+      </p:sp>
+      <p:sp>
+        <p:nvSpPr>
+          <p:cNvPr id="3" name="TextBox 2"/>
+          <p:cNvSpPr txBox="1"/>
+          <p:nvPr/>
+        </p:nvSpPr>
+        <p:spPr>
+          <a:xfrm>
+            <a:off x="768096" y="365760"/>
+            <a:ext cx="7479792" cy="640080"/>
+          </a:xfrm>
+          <a:prstGeom prst="rect">
+            <a:avLst/>
+          </a:prstGeom>
+          <a:noFill/>
+        </p:spPr>
+        <p:txBody>
+          <a:bodyPr wrap="square" anchor="t">
+            <a:spAutoFit/>
+          </a:bodyPr>
+          <a:lstStyle/>
+          <a:p>
+            <a:r>
+              <a:rPr sz="2600" b="1" i="0">
+                <a:solidFill>
+                  <a:srgbClr val="003A70"/>
+                </a:solidFill>
+                <a:latin typeface="Calibri"/>
+              </a:rPr>
+              <a:t>La solución: un sistema en 4 pasos</a:t>
+            </a:r>
+          </a:p>
+        </p:txBody>
+      </p:sp>
+      <p:sp>
+        <p:nvSpPr>
+          <p:cNvPr id="4" name="Rounded Rectangle 3"/>
+          <p:cNvSpPr/>
+          <p:nvPr/>
+        </p:nvSpPr>
+        <p:spPr>
+          <a:xfrm>
+            <a:off x="566928" y="1645920"/>
+            <a:ext cx="1783080" cy="2103120"/>
+          </a:xfrm>
+          <a:prstGeom prst="roundRect">
+            <a:avLst/>
+          </a:prstGeom>
+          <a:solidFill>
+            <a:srgbClr val="F3F6FB"/>
+          </a:solidFill>
+          <a:ln w="12700">
+            <a:solidFill>
+              <a:srgbClr val="0072CE"/>
+            </a:solidFill>
+          </a:ln>
+          <a:effectLst/>
+        </p:spPr>
+        <p:style>
+          <a:lnRef idx="1">
+            <a:schemeClr val="accent1"/>
+          </a:lnRef>
+          <a:fillRef idx="3">
+            <a:schemeClr val="accent1"/>
+          </a:fillRef>
+          <a:effectRef idx="2">
+            <a:schemeClr val="accent1"/>
+          </a:effectRef>
+          <a:fontRef idx="minor">
+            <a:schemeClr val="lt1"/>
+          </a:fontRef>
+        </p:style>
+        <p:txBody>
+          <a:bodyPr rtlCol="0" anchor="t" wrap="square"/>
+          <a:lstStyle/>
+          <a:p>
+            <a:pPr algn="ctr"/>
+            <a:r>
+              <a:rPr sz="3000" b="1" i="0">
+                <a:solidFill>
+                  <a:srgbClr val="C8961B"/>
+                </a:solidFill>
+                <a:latin typeface="Calibri"/>
+              </a:rPr>
+              <a:t>I</a:t>
+            </a:r>
+          </a:p>
+          <a:p>
+            <a:pPr algn="ctr"/>
+            <a:r>
+              <a:rPr sz="1350" b="1" i="0">
+                <a:solidFill>
+                  <a:srgbClr val="003A70"/>
+                </a:solidFill>
+                <a:latin typeface="Calibri"/>
+              </a:rPr>
+              <a:t>Recepción de Reportes</a:t>
+            </a:r>
+          </a:p>
+          <a:p>
+            <a:pPr algn="ctr"/>
+            <a:r>
+              <a:rPr sz="1150" b="0" i="0">
+                <a:solidFill>
+                  <a:srgbClr val="58595B"/>
+                </a:solidFill>
+                <a:latin typeface="Calibri"/>
+              </a:rPr>
+              <a:t>Cargar MEF + BCE (arrastrar)</a:t>
+            </a:r>
+          </a:p>
+        </p:txBody>
+      </p:sp>
+      <p:sp>
+        <p:nvSpPr>
+          <p:cNvPr id="5" name="Rounded Rectangle 4"/>
+          <p:cNvSpPr/>
+          <p:nvPr/>
+        </p:nvSpPr>
+        <p:spPr>
+          <a:xfrm>
+            <a:off x="2505456" y="1645920"/>
+            <a:ext cx="1783080" cy="2103120"/>
+          </a:xfrm>
+          <a:prstGeom prst="roundRect">
+            <a:avLst/>
+          </a:prstGeom>
+          <a:solidFill>
+            <a:srgbClr val="F3F6FB"/>
+          </a:solidFill>
+          <a:ln w="12700">
+            <a:solidFill>
+              <a:srgbClr val="0072CE"/>
+            </a:solidFill>
+          </a:ln>
+          <a:effectLst/>
+        </p:spPr>
+        <p:style>
+          <a:lnRef idx="1">
+            <a:schemeClr val="accent1"/>
+          </a:lnRef>
+          <a:fillRef idx="3">
+            <a:schemeClr val="accent1"/>
+          </a:fillRef>
+          <a:effectRef idx="2">
+            <a:schemeClr val="accent1"/>
+          </a:effectRef>
+          <a:fontRef idx="minor">
+            <a:schemeClr val="lt1"/>
+          </a:fontRef>
+        </p:style>
+        <p:txBody>
+          <a:bodyPr rtlCol="0" anchor="t" wrap="square"/>
+          <a:lstStyle/>
+          <a:p>
+            <a:pPr algn="ctr"/>
+            <a:r>
+              <a:rPr sz="3000" b="1" i="0">
+                <a:solidFill>
+                  <a:srgbClr val="C8961B"/>
+                </a:solidFill>
+                <a:latin typeface="Calibri"/>
+              </a:rPr>
+              <a:t>II</a:t>
+            </a:r>
+          </a:p>
+          <a:p>
+            <a:pPr algn="ctr"/>
+            <a:r>
+              <a:rPr sz="1350" b="1" i="0">
+                <a:solidFill>
+                  <a:srgbClr val="003A70"/>
+                </a:solidFill>
+                <a:latin typeface="Calibri"/>
+              </a:rPr>
+              <a:t>Conciliación de Carteras</a:t>
+            </a:r>
+          </a:p>
+          <a:p>
+            <a:pPr algn="ctr"/>
+            <a:r>
+              <a:rPr sz="1150" b="0" i="0">
+                <a:solidFill>
+                  <a:srgbClr val="58595B"/>
+                </a:solidFill>
+                <a:latin typeface="Calibri"/>
+              </a:rPr>
+              <a:t>Matriz con semáforo y total</a:t>
+            </a:r>
+          </a:p>
+        </p:txBody>
+      </p:sp>
+      <p:sp>
+        <p:nvSpPr>
+          <p:cNvPr id="6" name="Rounded Rectangle 5"/>
+          <p:cNvSpPr/>
+          <p:nvPr/>
+        </p:nvSpPr>
+        <p:spPr>
+          <a:xfrm>
+            <a:off x="4443984" y="1645920"/>
+            <a:ext cx="1783080" cy="2103120"/>
+          </a:xfrm>
+          <a:prstGeom prst="roundRect">
+            <a:avLst/>
+          </a:prstGeom>
+          <a:solidFill>
+            <a:srgbClr val="F3F6FB"/>
+          </a:solidFill>
+          <a:ln w="12700">
+            <a:solidFill>
+              <a:srgbClr val="0072CE"/>
+            </a:solidFill>
+          </a:ln>
+          <a:effectLst/>
+        </p:spPr>
+        <p:style>
+          <a:lnRef idx="1">
+            <a:schemeClr val="accent1"/>
+          </a:lnRef>
+          <a:fillRef idx="3">
+            <a:schemeClr val="accent1"/>
+          </a:fillRef>
+          <a:effectRef idx="2">
+            <a:schemeClr val="accent1"/>
+          </a:effectRef>
+          <a:fontRef idx="minor">
+            <a:schemeClr val="lt1"/>
+          </a:fontRef>
+        </p:style>
+        <p:txBody>
+          <a:bodyPr rtlCol="0" anchor="t" wrap="square"/>
+          <a:lstStyle/>
+          <a:p>
+            <a:pPr algn="ctr"/>
+            <a:r>
+              <a:rPr sz="3000" b="1" i="0">
+                <a:solidFill>
+                  <a:srgbClr val="C8961B"/>
+                </a:solidFill>
+                <a:latin typeface="Calibri"/>
+              </a:rPr>
+              <a:t>III</a:t>
+            </a:r>
+          </a:p>
+          <a:p>
+            <a:pPr algn="ctr"/>
+            <a:r>
+              <a:rPr sz="1350" b="1" i="0">
+                <a:solidFill>
+                  <a:srgbClr val="003A70"/>
+                </a:solidFill>
+                <a:latin typeface="Calibri"/>
+              </a:rPr>
+              <a:t>Gestión de Observaciones</a:t>
+            </a:r>
+          </a:p>
+          <a:p>
+            <a:pPr algn="ctr"/>
+            <a:r>
+              <a:rPr sz="1150" b="0" i="0">
+                <a:solidFill>
+                  <a:srgbClr val="58595B"/>
+                </a:solidFill>
+                <a:latin typeface="Calibri"/>
+              </a:rPr>
+              <a:t>Resolver lo que no cuadra</a:t>
+            </a:r>
+          </a:p>
+        </p:txBody>
+      </p:sp>
+      <p:sp>
+        <p:nvSpPr>
+          <p:cNvPr id="7" name="Rounded Rectangle 6"/>
+          <p:cNvSpPr/>
+          <p:nvPr/>
+        </p:nvSpPr>
+        <p:spPr>
+          <a:xfrm>
+            <a:off x="6382512" y="1645920"/>
+            <a:ext cx="1783080" cy="2103120"/>
+          </a:xfrm>
+          <a:prstGeom prst="roundRect">
+            <a:avLst/>
+          </a:prstGeom>
+          <a:solidFill>
+            <a:srgbClr val="F3F6FB"/>
+          </a:solidFill>
+          <a:ln w="12700">
+            <a:solidFill>
+              <a:srgbClr val="0072CE"/>
+            </a:solidFill>
+          </a:ln>
+          <a:effectLst/>
+        </p:spPr>
+        <p:style>
+          <a:lnRef idx="1">
+            <a:schemeClr val="accent1"/>
+          </a:lnRef>
+          <a:fillRef idx="3">
+            <a:schemeClr val="accent1"/>
+          </a:fillRef>
+          <a:effectRef idx="2">
+            <a:schemeClr val="accent1"/>
+          </a:effectRef>
+          <a:fontRef idx="minor">
+            <a:schemeClr val="lt1"/>
+          </a:fontRef>
+        </p:style>
+        <p:txBody>
+          <a:bodyPr rtlCol="0" anchor="t" wrap="square"/>
+          <a:lstStyle/>
+          <a:p>
+            <a:pPr algn="ctr"/>
+            <a:r>
+              <a:rPr sz="3000" b="1" i="0">
+                <a:solidFill>
+                  <a:srgbClr val="C8961B"/>
+                </a:solidFill>
+                <a:latin typeface="Calibri"/>
+              </a:rPr>
+              <a:t>IV</a:t>
+            </a:r>
+          </a:p>
+          <a:p>
+            <a:pPr algn="ctr"/>
+            <a:r>
+              <a:rPr sz="1350" b="1" i="0">
+                <a:solidFill>
+                  <a:srgbClr val="003A70"/>
+                </a:solidFill>
+                <a:latin typeface="Calibri"/>
+              </a:rPr>
+              <a:t>Emisión del Oficio</a:t>
+            </a:r>
+          </a:p>
+          <a:p>
+            <a:pPr algn="ctr"/>
+            <a:r>
+              <a:rPr sz="1150" b="0" i="0">
+                <a:solidFill>
+                  <a:srgbClr val="58595B"/>
+                </a:solidFill>
+                <a:latin typeface="Calibri"/>
+              </a:rPr>
+              <a:t>Generar el Quipux de respuesta</a:t>
+            </a:r>
+          </a:p>
+        </p:txBody>
+      </p:sp>
+    </p:spTree>
+  </p:cSld>
+  <p:clrMapOvr>
+    <a:masterClrMapping/>
+  </p:clrMapOvr>
+</p:sld>
+</file>
+
+<file path=ppt/slides/slide7.xml><?xml version="1.0" encoding="utf-8"?>
+<p:sld xmlns:a="http://schemas.openxmlformats.org/drawingml/2006/main" xmlns:p="http://schemas.openxmlformats.org/presentationml/2006/main" xmlns:r="http://schemas.openxmlformats.org/officeDocument/2006/relationships">
+  <p:cSld>
+    <p:spTree>
+      <p:nvGrpSpPr>
+        <p:cNvPr id="1" name=""/>
+        <p:cNvGrpSpPr/>
+        <p:nvPr/>
+      </p:nvGrpSpPr>
+      <p:grpSpPr/>
+      <p:sp>
+        <p:nvSpPr>
+          <p:cNvPr id="2" name="Rectangle 1"/>
+          <p:cNvSpPr/>
+          <p:nvPr/>
+        </p:nvSpPr>
+        <p:spPr>
+          <a:xfrm>
+            <a:off x="566928" y="411480"/>
+            <a:ext cx="82296" cy="457200"/>
+          </a:xfrm>
+          <a:prstGeom prst="rect">
+            <a:avLst/>
+          </a:prstGeom>
+          <a:solidFill>
+            <a:srgbClr val="C8961B"/>
+          </a:solidFill>
+          <a:ln>
+            <a:noFill/>
+          </a:ln>
+        </p:spPr>
+        <p:style>
+          <a:lnRef idx="1">
+            <a:schemeClr val="accent1"/>
+          </a:lnRef>
+          <a:fillRef idx="3">
+            <a:schemeClr val="accent1"/>
+          </a:fillRef>
+          <a:effectRef idx="2">
+            <a:schemeClr val="accent1"/>
+          </a:effectRef>
+          <a:fontRef idx="minor">
+            <a:schemeClr val="lt1"/>
+          </a:fontRef>
+        </p:style>
+        <p:txBody>
+          <a:bodyPr rtlCol="0" anchor="ctr"/>
+          <a:lstStyle/>
+          <a:p>
+            <a:pPr algn="ctr"/>
+          </a:p>
+        </p:txBody>
+      </p:sp>
+      <p:sp>
+        <p:nvSpPr>
+          <p:cNvPr id="3" name="TextBox 2"/>
+          <p:cNvSpPr txBox="1"/>
+          <p:nvPr/>
+        </p:nvSpPr>
+        <p:spPr>
+          <a:xfrm>
+            <a:off x="768096" y="365760"/>
+            <a:ext cx="7479792" cy="640080"/>
+          </a:xfrm>
+          <a:prstGeom prst="rect">
+            <a:avLst/>
+          </a:prstGeom>
+          <a:noFill/>
+        </p:spPr>
+        <p:txBody>
+          <a:bodyPr wrap="square" anchor="t">
+            <a:spAutoFit/>
+          </a:bodyPr>
+          <a:lstStyle/>
+          <a:p>
+            <a:r>
+              <a:rPr sz="2600" b="1" i="0">
+                <a:solidFill>
+                  <a:srgbClr val="003A70"/>
+                </a:solidFill>
+                <a:latin typeface="Calibri"/>
+              </a:rPr>
+              <a:t>Paso I · Recepción de Reportes</a:t>
+            </a:r>
+          </a:p>
+        </p:txBody>
+      </p:sp>
+      <p:sp>
+        <p:nvSpPr>
+          <p:cNvPr id="4" name="TextBox 3"/>
+          <p:cNvSpPr txBox="1"/>
+          <p:nvPr/>
+        </p:nvSpPr>
+        <p:spPr>
+          <a:xfrm>
+            <a:off x="768096" y="932688"/>
+            <a:ext cx="7479792" cy="365760"/>
+          </a:xfrm>
+          <a:prstGeom prst="rect">
+            <a:avLst/>
+          </a:prstGeom>
+          <a:noFill/>
+        </p:spPr>
+        <p:txBody>
+          <a:bodyPr wrap="square" anchor="t">
+            <a:spAutoFit/>
+          </a:bodyPr>
+          <a:lstStyle/>
+          <a:p>
+            <a:r>
+              <a:rPr sz="1300" b="0" i="1">
+                <a:solidFill>
+                  <a:srgbClr val="8A8C8F"/>
+                </a:solidFill>
+                <a:latin typeface="Calibri"/>
+              </a:rPr>
+              <a:t>Carga inteligente</a:t>
+            </a:r>
+          </a:p>
+        </p:txBody>
+      </p:sp>
+      <p:pic>
+        <p:nvPicPr>
+          <p:cNvPr id="5" name="Picture 4" descr="s1_carga.png"/>
+          <p:cNvPicPr>
+            <a:picLocks noChangeAspect="1"/>
+          </p:cNvPicPr>
+          <p:nvPr/>
+        </p:nvPicPr>
+        <p:blipFill>
+          <a:blip r:embed="rId2"/>
+          <a:stretch>
+            <a:fillRect/>
+          </a:stretch>
+        </p:blipFill>
+        <p:spPr>
+          <a:xfrm>
+            <a:off x="1394460" y="1097280"/>
+            <a:ext cx="6355080" cy="3575304"/>
+          </a:xfrm>
+          <a:prstGeom prst="rect">
+            <a:avLst/>
+          </a:prstGeom>
+          <a:ln w="9525">
+            <a:solidFill>
+              <a:srgbClr val="0072CE"/>
+            </a:solidFill>
+          </a:ln>
+        </p:spPr>
+      </p:pic>
+      <p:sp>
+        <p:nvSpPr>
+          <p:cNvPr id="6" name="TextBox 5"/>
+          <p:cNvSpPr txBox="1"/>
+          <p:nvPr/>
+        </p:nvSpPr>
+        <p:spPr>
+          <a:xfrm>
+            <a:off x="548640" y="4736592"/>
+            <a:ext cx="8046720" cy="320040"/>
+          </a:xfrm>
+          <a:prstGeom prst="rect">
+            <a:avLst/>
+          </a:prstGeom>
+          <a:noFill/>
+        </p:spPr>
+        <p:txBody>
+          <a:bodyPr wrap="square" anchor="t">
+            <a:spAutoFit/>
+          </a:bodyPr>
+          <a:lstStyle/>
+          <a:p>
+            <a:pPr algn="ctr"/>
+            <a:r>
+              <a:rPr sz="1100" b="0" i="1">
+                <a:solidFill>
+                  <a:srgbClr val="8A8C8F"/>
+                </a:solidFill>
+                <a:latin typeface="Calibri"/>
+              </a:rPr>
+              <a:t>Una sola zona: se arrastran los dos reportes (MEF y BCE); el período se detecta automáticamente.</a:t>
+            </a:r>
+          </a:p>
+        </p:txBody>
+      </p:sp>
+    </p:spTree>
+  </p:cSld>
+  <p:clrMapOvr>
+    <a:masterClrMapping/>
+  </p:clrMapOvr>
+</p:sld>
+</file>
+
+<file path=ppt/slides/slide8.xml><?xml version="1.0" encoding="utf-8"?>
+<p:sld xmlns:a="http://schemas.openxmlformats.org/drawingml/2006/main" xmlns:p="http://schemas.openxmlformats.org/presentationml/2006/main" xmlns:r="http://schemas.openxmlformats.org/officeDocument/2006/relationships">
+  <p:cSld>
+    <p:spTree>
+      <p:nvGrpSpPr>
+        <p:cNvPr id="1" name=""/>
+        <p:cNvGrpSpPr/>
+        <p:nvPr/>
+      </p:nvGrpSpPr>
+      <p:grpSpPr/>
+      <p:sp>
+        <p:nvSpPr>
+          <p:cNvPr id="2" name="Rectangle 1"/>
+          <p:cNvSpPr/>
+          <p:nvPr/>
+        </p:nvSpPr>
+        <p:spPr>
+          <a:xfrm>
+            <a:off x="566928" y="411480"/>
+            <a:ext cx="82296" cy="457200"/>
+          </a:xfrm>
+          <a:prstGeom prst="rect">
+            <a:avLst/>
+          </a:prstGeom>
+          <a:solidFill>
+            <a:srgbClr val="C8961B"/>
+          </a:solidFill>
+          <a:ln>
+            <a:noFill/>
+          </a:ln>
+        </p:spPr>
+        <p:style>
+          <a:lnRef idx="1">
+            <a:schemeClr val="accent1"/>
+          </a:lnRef>
+          <a:fillRef idx="3">
+            <a:schemeClr val="accent1"/>
+          </a:fillRef>
+          <a:effectRef idx="2">
+            <a:schemeClr val="accent1"/>
+          </a:effectRef>
+          <a:fontRef idx="minor">
+            <a:schemeClr val="lt1"/>
+          </a:fontRef>
+        </p:style>
+        <p:txBody>
+          <a:bodyPr rtlCol="0" anchor="ctr"/>
+          <a:lstStyle/>
+          <a:p>
+            <a:pPr algn="ctr"/>
+          </a:p>
+        </p:txBody>
+      </p:sp>
+      <p:sp>
+        <p:nvSpPr>
+          <p:cNvPr id="3" name="TextBox 2"/>
+          <p:cNvSpPr txBox="1"/>
+          <p:nvPr/>
+        </p:nvSpPr>
+        <p:spPr>
+          <a:xfrm>
+            <a:off x="768096" y="365760"/>
+            <a:ext cx="7479792" cy="640080"/>
+          </a:xfrm>
+          <a:prstGeom prst="rect">
+            <a:avLst/>
+          </a:prstGeom>
+          <a:noFill/>
+        </p:spPr>
+        <p:txBody>
+          <a:bodyPr wrap="square" anchor="t">
+            <a:spAutoFit/>
+          </a:bodyPr>
+          <a:lstStyle/>
+          <a:p>
+            <a:r>
+              <a:rPr sz="2600" b="1" i="0">
+                <a:solidFill>
+                  <a:srgbClr val="003A70"/>
+                </a:solidFill>
+                <a:latin typeface="Calibri"/>
+              </a:rPr>
+              <a:t>Paso II · Conciliación de Carteras</a:t>
+            </a:r>
+          </a:p>
+        </p:txBody>
+      </p:sp>
+      <p:sp>
+        <p:nvSpPr>
+          <p:cNvPr id="4" name="TextBox 3"/>
+          <p:cNvSpPr txBox="1"/>
+          <p:nvPr/>
+        </p:nvSpPr>
+        <p:spPr>
+          <a:xfrm>
+            <a:off x="768096" y="932688"/>
+            <a:ext cx="7479792" cy="365760"/>
+          </a:xfrm>
+          <a:prstGeom prst="rect">
+            <a:avLst/>
+          </a:prstGeom>
+          <a:noFill/>
+        </p:spPr>
+        <p:txBody>
+          <a:bodyPr wrap="square" anchor="t">
+            <a:spAutoFit/>
+          </a:bodyPr>
+          <a:lstStyle/>
+          <a:p>
+            <a:r>
+              <a:rPr sz="1300" b="0" i="1">
+                <a:solidFill>
+                  <a:srgbClr val="8A8C8F"/>
+                </a:solidFill>
+                <a:latin typeface="Calibri"/>
+              </a:rPr>
+              <a:t>Matriz con semáforo y total general</a:t>
+            </a:r>
+          </a:p>
+        </p:txBody>
+      </p:sp>
+      <p:pic>
+        <p:nvPicPr>
+          <p:cNvPr id="5" name="Picture 4" descr="s2_resultados.png"/>
+          <p:cNvPicPr>
+            <a:picLocks noChangeAspect="1"/>
+          </p:cNvPicPr>
+          <p:nvPr/>
+        </p:nvPicPr>
+        <p:blipFill>
+          <a:blip r:embed="rId2"/>
+          <a:stretch>
+            <a:fillRect/>
+          </a:stretch>
+        </p:blipFill>
+        <p:spPr>
+          <a:xfrm>
+            <a:off x="1394460" y="1097280"/>
+            <a:ext cx="6355080" cy="3575304"/>
+          </a:xfrm>
+          <a:prstGeom prst="rect">
+            <a:avLst/>
+          </a:prstGeom>
+          <a:ln w="9525">
+            <a:solidFill>
+              <a:srgbClr val="0072CE"/>
+            </a:solidFill>
+          </a:ln>
+        </p:spPr>
+      </p:pic>
+      <p:sp>
+        <p:nvSpPr>
+          <p:cNvPr id="6" name="TextBox 5"/>
+          <p:cNvSpPr txBox="1"/>
+          <p:nvPr/>
+        </p:nvSpPr>
+        <p:spPr>
+          <a:xfrm>
+            <a:off x="548640" y="4736592"/>
+            <a:ext cx="8046720" cy="320040"/>
+          </a:xfrm>
+          <a:prstGeom prst="rect">
+            <a:avLst/>
+          </a:prstGeom>
+          <a:noFill/>
+        </p:spPr>
+        <p:txBody>
+          <a:bodyPr wrap="square" anchor="t">
+            <a:spAutoFit/>
+          </a:bodyPr>
+          <a:lstStyle/>
+          <a:p>
+            <a:pPr algn="ctr"/>
+            <a:r>
+              <a:rPr sz="1100" b="0" i="1">
+                <a:solidFill>
+                  <a:srgbClr val="8A8C8F"/>
+                </a:solidFill>
+                <a:latin typeface="Calibri"/>
+              </a:rPr>
+              <a:t>Matriz por cartera (MEF · BCE · Δ). Rojo = diferencia. Suma préstamo por préstamo, exacto al centavo.</a:t>
+            </a:r>
+          </a:p>
+        </p:txBody>
+      </p:sp>
+    </p:spTree>
+  </p:cSld>
+  <p:clrMapOvr>
+    <a:masterClrMapping/>
+  </p:clrMapOvr>
+</p:sld>
+</file>
+
+<file path=ppt/slides/slide9.xml><?xml version="1.0" encoding="utf-8"?>
+<p:sld xmlns:a="http://schemas.openxmlformats.org/drawingml/2006/main" xmlns:p="http://schemas.openxmlformats.org/presentationml/2006/main" xmlns:r="http://schemas.openxmlformats.org/officeDocument/2006/relationships">
+  <p:cSld>
+    <p:spTree>
+      <p:nvGrpSpPr>
+        <p:cNvPr id="1" name=""/>
+        <p:cNvGrpSpPr/>
+        <p:nvPr/>
+      </p:nvGrpSpPr>
+      <p:grpSpPr/>
+      <p:sp>
+        <p:nvSpPr>
+          <p:cNvPr id="2" name="Rectangle 1"/>
+          <p:cNvSpPr/>
+          <p:nvPr/>
+        </p:nvSpPr>
+        <p:spPr>
+          <a:xfrm>
+            <a:off x="566928" y="411480"/>
+            <a:ext cx="82296" cy="457200"/>
+          </a:xfrm>
+          <a:prstGeom prst="rect">
+            <a:avLst/>
+          </a:prstGeom>
+          <a:solidFill>
+            <a:srgbClr val="C8961B"/>
+          </a:solidFill>
+          <a:ln>
+            <a:noFill/>
+          </a:ln>
+        </p:spPr>
+        <p:style>
+          <a:lnRef idx="1">
+            <a:schemeClr val="accent1"/>
+          </a:lnRef>
+          <a:fillRef idx="3">
+            <a:schemeClr val="accent1"/>
+          </a:fillRef>
+          <a:effectRef idx="2">
+            <a:schemeClr val="accent1"/>
+          </a:effectRef>
+          <a:fontRef idx="minor">
+            <a:schemeClr val="lt1"/>
+          </a:fontRef>
+        </p:style>
+        <p:txBody>
+          <a:bodyPr rtlCol="0" anchor="ctr"/>
+          <a:lstStyle/>
+          <a:p>
+            <a:pPr algn="ctr"/>
+          </a:p>
+        </p:txBody>
+      </p:sp>
+      <p:sp>
+        <p:nvSpPr>
+          <p:cNvPr id="3" name="TextBox 2"/>
+          <p:cNvSpPr txBox="1"/>
+          <p:nvPr/>
+        </p:nvSpPr>
+        <p:spPr>
+          <a:xfrm>
+            <a:off x="768096" y="365760"/>
+            <a:ext cx="7479792" cy="640080"/>
+          </a:xfrm>
+          <a:prstGeom prst="rect">
+            <a:avLst/>
+          </a:prstGeom>
+          <a:noFill/>
+        </p:spPr>
+        <p:txBody>
+          <a:bodyPr wrap="square" anchor="t">
+            <a:spAutoFit/>
+          </a:bodyPr>
+          <a:lstStyle/>
+          <a:p>
+            <a:r>
+              <a:rPr sz="2600" b="1" i="0">
+                <a:solidFill>
+                  <a:srgbClr val="003A70"/>
+                </a:solidFill>
+                <a:latin typeface="Calibri"/>
+              </a:rPr>
+              <a:t>Paso III · Gestión de Observaciones</a:t>
+            </a:r>
+          </a:p>
+        </p:txBody>
+      </p:sp>
+      <p:sp>
+        <p:nvSpPr>
+          <p:cNvPr id="4" name="TextBox 3"/>
+          <p:cNvSpPr txBox="1"/>
+          <p:nvPr/>
+        </p:nvSpPr>
+        <p:spPr>
+          <a:xfrm>
+            <a:off x="768096" y="932688"/>
+            <a:ext cx="7479792" cy="365760"/>
+          </a:xfrm>
+          <a:prstGeom prst="rect">
+            <a:avLst/>
+          </a:prstGeom>
+          <a:noFill/>
+        </p:spPr>
+        <p:txBody>
+          <a:bodyPr wrap="square" anchor="t">
+            <a:spAutoFit/>
+          </a:bodyPr>
+          <a:lstStyle/>
+          <a:p>
+            <a:r>
+              <a:rPr sz="1300" b="0" i="1">
+                <a:solidFill>
+                  <a:srgbClr val="8A8C8F"/>
+                </a:solidFill>
+                <a:latin typeface="Calibri"/>
+              </a:rPr>
+              <a:t>Identifica el préstamo exacto que no cuadra</a:t>
+            </a:r>
+          </a:p>
+        </p:txBody>
+      </p:sp>
+      <p:pic>
+        <p:nvPicPr>
+          <p:cNvPr id="5" name="Picture 4" descr="s3_observaciones.png"/>
+          <p:cNvPicPr>
+            <a:picLocks noChangeAspect="1"/>
+          </p:cNvPicPr>
+          <p:nvPr/>
+        </p:nvPicPr>
+        <p:blipFill>
+          <a:blip r:embed="rId2"/>
+          <a:stretch>
+            <a:fillRect/>
+          </a:stretch>
+        </p:blipFill>
+        <p:spPr>
+          <a:xfrm>
+            <a:off x="1394460" y="1097280"/>
+            <a:ext cx="6355080" cy="3575304"/>
+          </a:xfrm>
+          <a:prstGeom prst="rect">
+            <a:avLst/>
+          </a:prstGeom>
+          <a:ln w="9525">
+            <a:solidFill>
+              <a:srgbClr val="0072CE"/>
+            </a:solidFill>
+          </a:ln>
+        </p:spPr>
+      </p:pic>
+      <p:sp>
+        <p:nvSpPr>
+          <p:cNvPr id="6" name="TextBox 5"/>
+          <p:cNvSpPr txBox="1"/>
+          <p:nvPr/>
+        </p:nvSpPr>
+        <p:spPr>
+          <a:xfrm>
+            <a:off x="548640" y="4736592"/>
+            <a:ext cx="8046720" cy="320040"/>
+          </a:xfrm>
+          <a:prstGeom prst="rect">
+            <a:avLst/>
+          </a:prstGeom>
+          <a:noFill/>
+        </p:spPr>
+        <p:txBody>
+          <a:bodyPr wrap="square" anchor="t">
+            <a:spAutoFit/>
+          </a:bodyPr>
+          <a:lstStyle/>
+          <a:p>
+            <a:pPr algn="ctr"/>
+            <a:r>
+              <a:rPr sz="1100" b="0" i="1">
+                <a:solidFill>
+                  <a:srgbClr val="8A8C8F"/>
+                </a:solidFill>
+                <a:latin typeface="Calibri"/>
+              </a:rPr>
+              <a:t>Señala el crédito (ej. BIRF-8888), lo clasifica (Pago Directo) y permite subir el respaldo y agregarlo al BCE.</a:t>
+            </a:r>
+          </a:p>
+        </p:txBody>
+      </p:sp>
     </p:spTree>
   </p:cSld>
   <p:clrMapOvr>

</xml_diff>